<commit_message>
demo folder added with video and ppt
</commit_message>
<xml_diff>
--- a/presentation/StockPulse_DevOps_Capstone.pptx
+++ b/presentation/StockPulse_DevOps_Capstone.pptx
@@ -5,21 +5,21 @@
     <p:sldMasterId id="2147483648" r:id="rId1"/>
   </p:sldMasterIdLst>
   <p:sldIdLst>
-    <p:sldId id="256" r:id="rId7"/>
-    <p:sldId id="257" r:id="rId8"/>
-    <p:sldId id="258" r:id="rId9"/>
-    <p:sldId id="259" r:id="rId10"/>
-    <p:sldId id="260" r:id="rId11"/>
-    <p:sldId id="261" r:id="rId12"/>
-    <p:sldId id="262" r:id="rId13"/>
-    <p:sldId id="263" r:id="rId14"/>
-    <p:sldId id="264" r:id="rId15"/>
-    <p:sldId id="265" r:id="rId16"/>
-    <p:sldId id="266" r:id="rId17"/>
-    <p:sldId id="267" r:id="rId18"/>
-    <p:sldId id="268" r:id="rId19"/>
+    <p:sldId id="256" r:id="rId2"/>
+    <p:sldId id="257" r:id="rId3"/>
+    <p:sldId id="258" r:id="rId4"/>
+    <p:sldId id="259" r:id="rId5"/>
+    <p:sldId id="260" r:id="rId6"/>
+    <p:sldId id="261" r:id="rId7"/>
+    <p:sldId id="262" r:id="rId8"/>
+    <p:sldId id="263" r:id="rId9"/>
+    <p:sldId id="264" r:id="rId10"/>
+    <p:sldId id="265" r:id="rId11"/>
+    <p:sldId id="266" r:id="rId12"/>
+    <p:sldId id="267" r:id="rId13"/>
+    <p:sldId id="268" r:id="rId14"/>
   </p:sldIdLst>
-  <p:sldSz cx="12191695" cy="6858000" type="screen4x3"/>
+  <p:sldSz cx="12192000" cy="6858000"/>
   <p:notesSz cx="6858000" cy="9144000"/>
   <p:defaultTextStyle>
     <a:defPPr>
@@ -116,7 +116,31 @@
       </a:defRPr>
     </a:lvl9pPr>
   </p:defaultTextStyle>
+  <p:extLst>
+    <p:ext uri="{EFAFB233-063F-42B5-8137-9DF3F51BA10A}">
+      <p15:sldGuideLst xmlns:p15="http://schemas.microsoft.com/office/powerpoint/2012/main">
+        <p15:guide id="1" orient="horz" pos="2160">
+          <p15:clr>
+            <a:srgbClr val="A4A3A4"/>
+          </p15:clr>
+        </p15:guide>
+        <p15:guide id="2" pos="2880">
+          <p15:clr>
+            <a:srgbClr val="A4A3A4"/>
+          </p15:clr>
+        </p15:guide>
+      </p15:sldGuideLst>
+    </p:ext>
+  </p:extLst>
 </p:presentation>
+</file>
+
+<file path=ppt/revisionInfo.xml><?xml version="1.0" encoding="utf-8"?>
+<p1510:revInfo xmlns:a="http://schemas.openxmlformats.org/drawingml/2006/main" xmlns:r="http://schemas.openxmlformats.org/officeDocument/2006/relationships" xmlns:p1510="http://schemas.microsoft.com/office/powerpoint/2015/10/main">
+  <p1510:revLst>
+    <p1510:client id="{039E137E-60E8-439D-83A6-1E9604C16C7C}" v="90" dt="2026-10-28T06:20:07.283"/>
+  </p1510:revLst>
+</p1510:revInfo>
 </file>
 
 <file path=ppt/slideLayouts/slideLayout1.xml><?xml version="1.0" encoding="utf-8"?>
@@ -157,10 +181,9 @@
           <a:lstStyle/>
           <a:p>
             <a:r>
-              <a:rPr lang="en-US" smtClean="0"/>
+              <a:rPr lang="en-US"/>
               <a:t>Click to edit Master title style</a:t>
             </a:r>
-            <a:endParaRPr lang="en-US"/>
           </a:p>
         </p:txBody>
       </p:sp>
@@ -276,10 +299,9 @@
           </a:lstStyle>
           <a:p>
             <a:r>
-              <a:rPr lang="en-US" smtClean="0"/>
+              <a:rPr lang="en-US"/>
               <a:t>Click to edit Master subtitle style</a:t>
             </a:r>
-            <a:endParaRPr lang="en-US"/>
           </a:p>
         </p:txBody>
       </p:sp>
@@ -300,7 +322,7 @@
           <a:p>
             <a:fld id="{5BCAD085-E8A6-8845-BD4E-CB4CCA059FC4}" type="datetimeFigureOut">
               <a:rPr lang="en-US" smtClean="0"/>
-              <a:t>1/27/13</a:t>
+              <a:t>10/27/2026</a:t>
             </a:fld>
             <a:endParaRPr lang="en-US"/>
           </a:p>
@@ -394,10 +416,9 @@
           <a:lstStyle/>
           <a:p>
             <a:r>
-              <a:rPr lang="en-US" smtClean="0"/>
+              <a:rPr lang="en-US"/>
               <a:t>Click to edit Master title style</a:t>
             </a:r>
-            <a:endParaRPr lang="en-US"/>
           </a:p>
         </p:txBody>
       </p:sp>
@@ -418,38 +439,37 @@
           <a:p>
             <a:pPr lvl="0"/>
             <a:r>
-              <a:rPr lang="en-US" smtClean="0"/>
+              <a:rPr lang="en-US"/>
               <a:t>Click to edit Master text styles</a:t>
             </a:r>
           </a:p>
           <a:p>
             <a:pPr lvl="1"/>
             <a:r>
-              <a:rPr lang="en-US" smtClean="0"/>
+              <a:rPr lang="en-US"/>
               <a:t>Second level</a:t>
             </a:r>
           </a:p>
           <a:p>
             <a:pPr lvl="2"/>
             <a:r>
-              <a:rPr lang="en-US" smtClean="0"/>
+              <a:rPr lang="en-US"/>
               <a:t>Third level</a:t>
             </a:r>
           </a:p>
           <a:p>
             <a:pPr lvl="3"/>
             <a:r>
-              <a:rPr lang="en-US" smtClean="0"/>
+              <a:rPr lang="en-US"/>
               <a:t>Fourth level</a:t>
             </a:r>
           </a:p>
           <a:p>
             <a:pPr lvl="4"/>
             <a:r>
-              <a:rPr lang="en-US" smtClean="0"/>
+              <a:rPr lang="en-US"/>
               <a:t>Fifth level</a:t>
             </a:r>
-            <a:endParaRPr lang="en-US"/>
           </a:p>
         </p:txBody>
       </p:sp>
@@ -470,7 +490,7 @@
           <a:p>
             <a:fld id="{5BCAD085-E8A6-8845-BD4E-CB4CCA059FC4}" type="datetimeFigureOut">
               <a:rPr lang="en-US" smtClean="0"/>
-              <a:t>1/27/13</a:t>
+              <a:t>10/27/2026</a:t>
             </a:fld>
             <a:endParaRPr lang="en-US"/>
           </a:p>
@@ -569,10 +589,9 @@
           <a:lstStyle/>
           <a:p>
             <a:r>
-              <a:rPr lang="en-US" smtClean="0"/>
+              <a:rPr lang="en-US"/>
               <a:t>Click to edit Master title style</a:t>
             </a:r>
-            <a:endParaRPr lang="en-US"/>
           </a:p>
         </p:txBody>
       </p:sp>
@@ -598,38 +617,37 @@
           <a:p>
             <a:pPr lvl="0"/>
             <a:r>
-              <a:rPr lang="en-US" smtClean="0"/>
+              <a:rPr lang="en-US"/>
               <a:t>Click to edit Master text styles</a:t>
             </a:r>
           </a:p>
           <a:p>
             <a:pPr lvl="1"/>
             <a:r>
-              <a:rPr lang="en-US" smtClean="0"/>
+              <a:rPr lang="en-US"/>
               <a:t>Second level</a:t>
             </a:r>
           </a:p>
           <a:p>
             <a:pPr lvl="2"/>
             <a:r>
-              <a:rPr lang="en-US" smtClean="0"/>
+              <a:rPr lang="en-US"/>
               <a:t>Third level</a:t>
             </a:r>
           </a:p>
           <a:p>
             <a:pPr lvl="3"/>
             <a:r>
-              <a:rPr lang="en-US" smtClean="0"/>
+              <a:rPr lang="en-US"/>
               <a:t>Fourth level</a:t>
             </a:r>
           </a:p>
           <a:p>
             <a:pPr lvl="4"/>
             <a:r>
-              <a:rPr lang="en-US" smtClean="0"/>
+              <a:rPr lang="en-US"/>
               <a:t>Fifth level</a:t>
             </a:r>
-            <a:endParaRPr lang="en-US"/>
           </a:p>
         </p:txBody>
       </p:sp>
@@ -650,7 +668,7 @@
           <a:p>
             <a:fld id="{5BCAD085-E8A6-8845-BD4E-CB4CCA059FC4}" type="datetimeFigureOut">
               <a:rPr lang="en-US" smtClean="0"/>
-              <a:t>1/27/13</a:t>
+              <a:t>10/27/2026</a:t>
             </a:fld>
             <a:endParaRPr lang="en-US"/>
           </a:p>
@@ -744,10 +762,9 @@
           <a:lstStyle/>
           <a:p>
             <a:r>
-              <a:rPr lang="en-US" smtClean="0"/>
+              <a:rPr lang="en-US"/>
               <a:t>Click to edit Master title style</a:t>
             </a:r>
-            <a:endParaRPr lang="en-US"/>
           </a:p>
         </p:txBody>
       </p:sp>
@@ -768,38 +785,37 @@
           <a:p>
             <a:pPr lvl="0"/>
             <a:r>
-              <a:rPr lang="en-US" smtClean="0"/>
+              <a:rPr lang="en-US"/>
               <a:t>Click to edit Master text styles</a:t>
             </a:r>
           </a:p>
           <a:p>
             <a:pPr lvl="1"/>
             <a:r>
-              <a:rPr lang="en-US" smtClean="0"/>
+              <a:rPr lang="en-US"/>
               <a:t>Second level</a:t>
             </a:r>
           </a:p>
           <a:p>
             <a:pPr lvl="2"/>
             <a:r>
-              <a:rPr lang="en-US" smtClean="0"/>
+              <a:rPr lang="en-US"/>
               <a:t>Third level</a:t>
             </a:r>
           </a:p>
           <a:p>
             <a:pPr lvl="3"/>
             <a:r>
-              <a:rPr lang="en-US" smtClean="0"/>
+              <a:rPr lang="en-US"/>
               <a:t>Fourth level</a:t>
             </a:r>
           </a:p>
           <a:p>
             <a:pPr lvl="4"/>
             <a:r>
-              <a:rPr lang="en-US" smtClean="0"/>
+              <a:rPr lang="en-US"/>
               <a:t>Fifth level</a:t>
             </a:r>
-            <a:endParaRPr lang="en-US"/>
           </a:p>
         </p:txBody>
       </p:sp>
@@ -820,7 +836,7 @@
           <a:p>
             <a:fld id="{5BCAD085-E8A6-8845-BD4E-CB4CCA059FC4}" type="datetimeFigureOut">
               <a:rPr lang="en-US" smtClean="0"/>
-              <a:t>1/27/13</a:t>
+              <a:t>10/27/2026</a:t>
             </a:fld>
             <a:endParaRPr lang="en-US"/>
           </a:p>
@@ -923,10 +939,9 @@
           </a:lstStyle>
           <a:p>
             <a:r>
-              <a:rPr lang="en-US" smtClean="0"/>
+              <a:rPr lang="en-US"/>
               <a:t>Click to edit Master title style</a:t>
             </a:r>
-            <a:endParaRPr lang="en-US"/>
           </a:p>
         </p:txBody>
       </p:sp>
@@ -1043,7 +1058,7 @@
           <a:p>
             <a:pPr lvl="0"/>
             <a:r>
-              <a:rPr lang="en-US" smtClean="0"/>
+              <a:rPr lang="en-US"/>
               <a:t>Click to edit Master text styles</a:t>
             </a:r>
           </a:p>
@@ -1066,7 +1081,7 @@
           <a:p>
             <a:fld id="{5BCAD085-E8A6-8845-BD4E-CB4CCA059FC4}" type="datetimeFigureOut">
               <a:rPr lang="en-US" smtClean="0"/>
-              <a:t>1/27/13</a:t>
+              <a:t>10/27/2026</a:t>
             </a:fld>
             <a:endParaRPr lang="en-US"/>
           </a:p>
@@ -1160,10 +1175,9 @@
           <a:lstStyle/>
           <a:p>
             <a:r>
-              <a:rPr lang="en-US" smtClean="0"/>
+              <a:rPr lang="en-US"/>
               <a:t>Click to edit Master title style</a:t>
             </a:r>
-            <a:endParaRPr lang="en-US"/>
           </a:p>
         </p:txBody>
       </p:sp>
@@ -1217,38 +1231,37 @@
           <a:p>
             <a:pPr lvl="0"/>
             <a:r>
-              <a:rPr lang="en-US" smtClean="0"/>
+              <a:rPr lang="en-US"/>
               <a:t>Click to edit Master text styles</a:t>
             </a:r>
           </a:p>
           <a:p>
             <a:pPr lvl="1"/>
             <a:r>
-              <a:rPr lang="en-US" smtClean="0"/>
+              <a:rPr lang="en-US"/>
               <a:t>Second level</a:t>
             </a:r>
           </a:p>
           <a:p>
             <a:pPr lvl="2"/>
             <a:r>
-              <a:rPr lang="en-US" smtClean="0"/>
+              <a:rPr lang="en-US"/>
               <a:t>Third level</a:t>
             </a:r>
           </a:p>
           <a:p>
             <a:pPr lvl="3"/>
             <a:r>
-              <a:rPr lang="en-US" smtClean="0"/>
+              <a:rPr lang="en-US"/>
               <a:t>Fourth level</a:t>
             </a:r>
           </a:p>
           <a:p>
             <a:pPr lvl="4"/>
             <a:r>
-              <a:rPr lang="en-US" smtClean="0"/>
+              <a:rPr lang="en-US"/>
               <a:t>Fifth level</a:t>
             </a:r>
-            <a:endParaRPr lang="en-US"/>
           </a:p>
         </p:txBody>
       </p:sp>
@@ -1302,38 +1315,37 @@
           <a:p>
             <a:pPr lvl="0"/>
             <a:r>
-              <a:rPr lang="en-US" smtClean="0"/>
+              <a:rPr lang="en-US"/>
               <a:t>Click to edit Master text styles</a:t>
             </a:r>
           </a:p>
           <a:p>
             <a:pPr lvl="1"/>
             <a:r>
-              <a:rPr lang="en-US" smtClean="0"/>
+              <a:rPr lang="en-US"/>
               <a:t>Second level</a:t>
             </a:r>
           </a:p>
           <a:p>
             <a:pPr lvl="2"/>
             <a:r>
-              <a:rPr lang="en-US" smtClean="0"/>
+              <a:rPr lang="en-US"/>
               <a:t>Third level</a:t>
             </a:r>
           </a:p>
           <a:p>
             <a:pPr lvl="3"/>
             <a:r>
-              <a:rPr lang="en-US" smtClean="0"/>
+              <a:rPr lang="en-US"/>
               <a:t>Fourth level</a:t>
             </a:r>
           </a:p>
           <a:p>
             <a:pPr lvl="4"/>
             <a:r>
-              <a:rPr lang="en-US" smtClean="0"/>
+              <a:rPr lang="en-US"/>
               <a:t>Fifth level</a:t>
             </a:r>
-            <a:endParaRPr lang="en-US"/>
           </a:p>
         </p:txBody>
       </p:sp>
@@ -1354,7 +1366,7 @@
           <a:p>
             <a:fld id="{5BCAD085-E8A6-8845-BD4E-CB4CCA059FC4}" type="datetimeFigureOut">
               <a:rPr lang="en-US" smtClean="0"/>
-              <a:t>1/27/13</a:t>
+              <a:t>10/27/2026</a:t>
             </a:fld>
             <a:endParaRPr lang="en-US"/>
           </a:p>
@@ -1452,10 +1464,9 @@
           </a:lstStyle>
           <a:p>
             <a:r>
-              <a:rPr lang="en-US" smtClean="0"/>
+              <a:rPr lang="en-US"/>
               <a:t>Click to edit Master title style</a:t>
             </a:r>
-            <a:endParaRPr lang="en-US"/>
           </a:p>
         </p:txBody>
       </p:sp>
@@ -1518,7 +1529,7 @@
           <a:p>
             <a:pPr lvl="0"/>
             <a:r>
-              <a:rPr lang="en-US" smtClean="0"/>
+              <a:rPr lang="en-US"/>
               <a:t>Click to edit Master text styles</a:t>
             </a:r>
           </a:p>
@@ -1574,38 +1585,37 @@
           <a:p>
             <a:pPr lvl="0"/>
             <a:r>
-              <a:rPr lang="en-US" smtClean="0"/>
+              <a:rPr lang="en-US"/>
               <a:t>Click to edit Master text styles</a:t>
             </a:r>
           </a:p>
           <a:p>
             <a:pPr lvl="1"/>
             <a:r>
-              <a:rPr lang="en-US" smtClean="0"/>
+              <a:rPr lang="en-US"/>
               <a:t>Second level</a:t>
             </a:r>
           </a:p>
           <a:p>
             <a:pPr lvl="2"/>
             <a:r>
-              <a:rPr lang="en-US" smtClean="0"/>
+              <a:rPr lang="en-US"/>
               <a:t>Third level</a:t>
             </a:r>
           </a:p>
           <a:p>
             <a:pPr lvl="3"/>
             <a:r>
-              <a:rPr lang="en-US" smtClean="0"/>
+              <a:rPr lang="en-US"/>
               <a:t>Fourth level</a:t>
             </a:r>
           </a:p>
           <a:p>
             <a:pPr lvl="4"/>
             <a:r>
-              <a:rPr lang="en-US" smtClean="0"/>
+              <a:rPr lang="en-US"/>
               <a:t>Fifth level</a:t>
             </a:r>
-            <a:endParaRPr lang="en-US"/>
           </a:p>
         </p:txBody>
       </p:sp>
@@ -1668,7 +1678,7 @@
           <a:p>
             <a:pPr lvl="0"/>
             <a:r>
-              <a:rPr lang="en-US" smtClean="0"/>
+              <a:rPr lang="en-US"/>
               <a:t>Click to edit Master text styles</a:t>
             </a:r>
           </a:p>
@@ -1724,38 +1734,37 @@
           <a:p>
             <a:pPr lvl="0"/>
             <a:r>
-              <a:rPr lang="en-US" smtClean="0"/>
+              <a:rPr lang="en-US"/>
               <a:t>Click to edit Master text styles</a:t>
             </a:r>
           </a:p>
           <a:p>
             <a:pPr lvl="1"/>
             <a:r>
-              <a:rPr lang="en-US" smtClean="0"/>
+              <a:rPr lang="en-US"/>
               <a:t>Second level</a:t>
             </a:r>
           </a:p>
           <a:p>
             <a:pPr lvl="2"/>
             <a:r>
-              <a:rPr lang="en-US" smtClean="0"/>
+              <a:rPr lang="en-US"/>
               <a:t>Third level</a:t>
             </a:r>
           </a:p>
           <a:p>
             <a:pPr lvl="3"/>
             <a:r>
-              <a:rPr lang="en-US" smtClean="0"/>
+              <a:rPr lang="en-US"/>
               <a:t>Fourth level</a:t>
             </a:r>
           </a:p>
           <a:p>
             <a:pPr lvl="4"/>
             <a:r>
-              <a:rPr lang="en-US" smtClean="0"/>
+              <a:rPr lang="en-US"/>
               <a:t>Fifth level</a:t>
             </a:r>
-            <a:endParaRPr lang="en-US"/>
           </a:p>
         </p:txBody>
       </p:sp>
@@ -1776,7 +1785,7 @@
           <a:p>
             <a:fld id="{5BCAD085-E8A6-8845-BD4E-CB4CCA059FC4}" type="datetimeFigureOut">
               <a:rPr lang="en-US" smtClean="0"/>
-              <a:t>1/27/13</a:t>
+              <a:t>10/27/2026</a:t>
             </a:fld>
             <a:endParaRPr lang="en-US"/>
           </a:p>
@@ -1870,10 +1879,9 @@
           <a:lstStyle/>
           <a:p>
             <a:r>
-              <a:rPr lang="en-US" smtClean="0"/>
+              <a:rPr lang="en-US"/>
               <a:t>Click to edit Master title style</a:t>
             </a:r>
-            <a:endParaRPr lang="en-US"/>
           </a:p>
         </p:txBody>
       </p:sp>
@@ -1894,7 +1902,7 @@
           <a:p>
             <a:fld id="{5BCAD085-E8A6-8845-BD4E-CB4CCA059FC4}" type="datetimeFigureOut">
               <a:rPr lang="en-US" smtClean="0"/>
-              <a:t>1/27/13</a:t>
+              <a:t>10/27/2026</a:t>
             </a:fld>
             <a:endParaRPr lang="en-US"/>
           </a:p>
@@ -1989,7 +1997,7 @@
           <a:p>
             <a:fld id="{5BCAD085-E8A6-8845-BD4E-CB4CCA059FC4}" type="datetimeFigureOut">
               <a:rPr lang="en-US" smtClean="0"/>
-              <a:t>1/27/13</a:t>
+              <a:t>10/27/2026</a:t>
             </a:fld>
             <a:endParaRPr lang="en-US"/>
           </a:p>
@@ -2092,10 +2100,9 @@
           </a:lstStyle>
           <a:p>
             <a:r>
-              <a:rPr lang="en-US" smtClean="0"/>
+              <a:rPr lang="en-US"/>
               <a:t>Click to edit Master title style</a:t>
             </a:r>
-            <a:endParaRPr lang="en-US"/>
           </a:p>
         </p:txBody>
       </p:sp>
@@ -2149,38 +2156,37 @@
           <a:p>
             <a:pPr lvl="0"/>
             <a:r>
-              <a:rPr lang="en-US" smtClean="0"/>
+              <a:rPr lang="en-US"/>
               <a:t>Click to edit Master text styles</a:t>
             </a:r>
           </a:p>
           <a:p>
             <a:pPr lvl="1"/>
             <a:r>
-              <a:rPr lang="en-US" smtClean="0"/>
+              <a:rPr lang="en-US"/>
               <a:t>Second level</a:t>
             </a:r>
           </a:p>
           <a:p>
             <a:pPr lvl="2"/>
             <a:r>
-              <a:rPr lang="en-US" smtClean="0"/>
+              <a:rPr lang="en-US"/>
               <a:t>Third level</a:t>
             </a:r>
           </a:p>
           <a:p>
             <a:pPr lvl="3"/>
             <a:r>
-              <a:rPr lang="en-US" smtClean="0"/>
+              <a:rPr lang="en-US"/>
               <a:t>Fourth level</a:t>
             </a:r>
           </a:p>
           <a:p>
             <a:pPr lvl="4"/>
             <a:r>
-              <a:rPr lang="en-US" smtClean="0"/>
+              <a:rPr lang="en-US"/>
               <a:t>Fifth level</a:t>
             </a:r>
-            <a:endParaRPr lang="en-US"/>
           </a:p>
         </p:txBody>
       </p:sp>
@@ -2243,7 +2249,7 @@
           <a:p>
             <a:pPr lvl="0"/>
             <a:r>
-              <a:rPr lang="en-US" smtClean="0"/>
+              <a:rPr lang="en-US"/>
               <a:t>Click to edit Master text styles</a:t>
             </a:r>
           </a:p>
@@ -2266,7 +2272,7 @@
           <a:p>
             <a:fld id="{5BCAD085-E8A6-8845-BD4E-CB4CCA059FC4}" type="datetimeFigureOut">
               <a:rPr lang="en-US" smtClean="0"/>
-              <a:t>1/27/13</a:t>
+              <a:t>10/27/2026</a:t>
             </a:fld>
             <a:endParaRPr lang="en-US"/>
           </a:p>
@@ -2369,10 +2375,9 @@
           </a:lstStyle>
           <a:p>
             <a:r>
-              <a:rPr lang="en-US" smtClean="0"/>
+              <a:rPr lang="en-US"/>
               <a:t>Click to edit Master title style</a:t>
             </a:r>
-            <a:endParaRPr lang="en-US"/>
           </a:p>
         </p:txBody>
       </p:sp>
@@ -2496,7 +2501,7 @@
           <a:p>
             <a:pPr lvl="0"/>
             <a:r>
-              <a:rPr lang="en-US" smtClean="0"/>
+              <a:rPr lang="en-US"/>
               <a:t>Click to edit Master text styles</a:t>
             </a:r>
           </a:p>
@@ -2519,7 +2524,7 @@
           <a:p>
             <a:fld id="{5BCAD085-E8A6-8845-BD4E-CB4CCA059FC4}" type="datetimeFigureOut">
               <a:rPr lang="en-US" smtClean="0"/>
-              <a:t>1/27/13</a:t>
+              <a:t>10/27/2026</a:t>
             </a:fld>
             <a:endParaRPr lang="en-US"/>
           </a:p>
@@ -2628,10 +2633,9 @@
           <a:lstStyle/>
           <a:p>
             <a:r>
-              <a:rPr lang="en-US" smtClean="0"/>
+              <a:rPr lang="en-US"/>
               <a:t>Click to edit Master title style</a:t>
             </a:r>
-            <a:endParaRPr lang="en-US"/>
           </a:p>
         </p:txBody>
       </p:sp>
@@ -2662,38 +2666,37 @@
           <a:p>
             <a:pPr lvl="0"/>
             <a:r>
-              <a:rPr lang="en-US" smtClean="0"/>
+              <a:rPr lang="en-US"/>
               <a:t>Click to edit Master text styles</a:t>
             </a:r>
           </a:p>
           <a:p>
             <a:pPr lvl="1"/>
             <a:r>
-              <a:rPr lang="en-US" smtClean="0"/>
+              <a:rPr lang="en-US"/>
               <a:t>Second level</a:t>
             </a:r>
           </a:p>
           <a:p>
             <a:pPr lvl="2"/>
             <a:r>
-              <a:rPr lang="en-US" smtClean="0"/>
+              <a:rPr lang="en-US"/>
               <a:t>Third level</a:t>
             </a:r>
           </a:p>
           <a:p>
             <a:pPr lvl="3"/>
             <a:r>
-              <a:rPr lang="en-US" smtClean="0"/>
+              <a:rPr lang="en-US"/>
               <a:t>Fourth level</a:t>
             </a:r>
           </a:p>
           <a:p>
             <a:pPr lvl="4"/>
             <a:r>
-              <a:rPr lang="en-US" smtClean="0"/>
+              <a:rPr lang="en-US"/>
               <a:t>Fifth level</a:t>
             </a:r>
-            <a:endParaRPr lang="en-US"/>
           </a:p>
         </p:txBody>
       </p:sp>
@@ -2732,7 +2735,7 @@
           <a:p>
             <a:fld id="{5BCAD085-E8A6-8845-BD4E-CB4CCA059FC4}" type="datetimeFigureOut">
               <a:rPr lang="en-US" smtClean="0"/>
-              <a:t>1/27/13</a:t>
+              <a:t>10/27/2026</a:t>
             </a:fld>
             <a:endParaRPr lang="en-US"/>
           </a:p>
@@ -3091,7 +3094,7 @@
 </file>
 
 <file path=ppt/slides/slide1.xml><?xml version="1.0" encoding="utf-8"?>
-<p:sld xmlns:a="http://schemas.openxmlformats.org/drawingml/2006/main" xmlns:p="http://schemas.openxmlformats.org/presentationml/2006/main" xmlns:r="http://schemas.openxmlformats.org/officeDocument/2006/relationships">
+<p:sld xmlns:a="http://schemas.openxmlformats.org/drawingml/2006/main" xmlns:r="http://schemas.openxmlformats.org/officeDocument/2006/relationships" xmlns:p="http://schemas.openxmlformats.org/presentationml/2006/main">
   <p:cSld>
     <p:spTree>
       <p:nvGrpSpPr>
@@ -3099,7 +3102,14 @@
         <p:cNvGrpSpPr/>
         <p:nvPr/>
       </p:nvGrpSpPr>
-      <p:grpSpPr/>
+      <p:grpSpPr>
+        <a:xfrm>
+          <a:off x="0" y="0"/>
+          <a:ext cx="0" cy="0"/>
+          <a:chOff x="0" y="0"/>
+          <a:chExt cx="0" cy="0"/>
+        </a:xfrm>
+      </p:grpSpPr>
       <p:sp>
         <p:nvSpPr>
           <p:cNvPr id="2" name="Rectangle 1"/>
@@ -3141,6 +3151,7 @@
           <a:lstStyle/>
           <a:p>
             <a:pPr algn="ctr"/>
+            <a:endParaRPr/>
           </a:p>
         </p:txBody>
       </p:sp>
@@ -3185,6 +3196,7 @@
           <a:lstStyle/>
           <a:p>
             <a:pPr algn="ctr"/>
+            <a:endParaRPr/>
           </a:p>
         </p:txBody>
       </p:sp>
@@ -3205,7 +3217,7 @@
           <a:noFill/>
         </p:spPr>
         <p:txBody>
-          <a:bodyPr wrap="square" lIns="0" rIns="0" tIns="0" bIns="0">
+          <a:bodyPr wrap="square" lIns="0" tIns="0" rIns="0" bIns="0">
             <a:spAutoFit/>
           </a:bodyPr>
           <a:lstStyle/>
@@ -3301,6 +3313,7 @@
           <a:lstStyle/>
           <a:p>
             <a:pPr algn="ctr"/>
+            <a:endParaRPr/>
           </a:p>
         </p:txBody>
       </p:sp>
@@ -3313,7 +3326,7 @@
         <p:spPr>
           <a:xfrm>
             <a:off x="1325880" y="4434840"/>
-            <a:ext cx="4754880" cy="566928"/>
+            <a:ext cx="4754880" cy="394980"/>
           </a:xfrm>
           <a:prstGeom prst="rect">
             <a:avLst/>
@@ -3321,7 +3334,7 @@
           <a:noFill/>
         </p:spPr>
         <p:txBody>
-          <a:bodyPr wrap="square" lIns="0" rIns="0" tIns="0" bIns="0">
+          <a:bodyPr wrap="square" lIns="0" tIns="0" rIns="0" bIns="0" anchor="t">
             <a:spAutoFit/>
           </a:bodyPr>
           <a:lstStyle/>
@@ -3351,7 +3364,7 @@
               </a:defRPr>
             </a:pPr>
             <a:r>
-              <a:t>Kapil Masih</a:t>
+              <a:t>Kapil </a:t>
             </a:r>
           </a:p>
         </p:txBody>
@@ -3373,7 +3386,7 @@
           <a:noFill/>
         </p:spPr>
         <p:txBody>
-          <a:bodyPr wrap="square" lIns="0" rIns="0" tIns="0" bIns="0">
+          <a:bodyPr wrap="square" lIns="0" tIns="0" rIns="0" bIns="0">
             <a:spAutoFit/>
           </a:bodyPr>
           <a:lstStyle/>
@@ -3425,7 +3438,7 @@
           <a:noFill/>
         </p:spPr>
         <p:txBody>
-          <a:bodyPr wrap="square" lIns="0" rIns="0" tIns="0" bIns="0">
+          <a:bodyPr wrap="square" lIns="0" tIns="0" rIns="0" bIns="0">
             <a:spAutoFit/>
           </a:bodyPr>
           <a:lstStyle/>
@@ -3477,7 +3490,7 @@
           <a:noFill/>
         </p:spPr>
         <p:txBody>
-          <a:bodyPr wrap="square" lIns="0" rIns="0" tIns="0" bIns="0">
+          <a:bodyPr wrap="square" lIns="0" tIns="0" rIns="0" bIns="0">
             <a:spAutoFit/>
           </a:bodyPr>
           <a:lstStyle/>
@@ -3529,7 +3542,7 @@
           <a:noFill/>
         </p:spPr>
         <p:txBody>
-          <a:bodyPr wrap="square" lIns="0" rIns="0" tIns="0" bIns="0">
+          <a:bodyPr wrap="square" lIns="0" tIns="0" rIns="0" bIns="0">
             <a:spAutoFit/>
           </a:bodyPr>
           <a:lstStyle/>
@@ -3557,7 +3570,7 @@
 </file>
 
 <file path=ppt/slides/slide10.xml><?xml version="1.0" encoding="utf-8"?>
-<p:sld xmlns:a="http://schemas.openxmlformats.org/drawingml/2006/main" xmlns:p="http://schemas.openxmlformats.org/presentationml/2006/main" xmlns:r="http://schemas.openxmlformats.org/officeDocument/2006/relationships">
+<p:sld xmlns:a="http://schemas.openxmlformats.org/drawingml/2006/main" xmlns:r="http://schemas.openxmlformats.org/officeDocument/2006/relationships" xmlns:p="http://schemas.openxmlformats.org/presentationml/2006/main">
   <p:cSld>
     <p:spTree>
       <p:nvGrpSpPr>
@@ -3565,7 +3578,14 @@
         <p:cNvGrpSpPr/>
         <p:nvPr/>
       </p:nvGrpSpPr>
-      <p:grpSpPr/>
+      <p:grpSpPr>
+        <a:xfrm>
+          <a:off x="0" y="0"/>
+          <a:ext cx="0" cy="0"/>
+          <a:chOff x="0" y="0"/>
+          <a:chExt cx="0" cy="0"/>
+        </a:xfrm>
+      </p:grpSpPr>
       <p:sp>
         <p:nvSpPr>
           <p:cNvPr id="2" name="Rectangle 1"/>
@@ -3607,6 +3627,7 @@
           <a:lstStyle/>
           <a:p>
             <a:pPr algn="ctr"/>
+            <a:endParaRPr/>
           </a:p>
         </p:txBody>
       </p:sp>
@@ -3651,6 +3672,7 @@
           <a:lstStyle/>
           <a:p>
             <a:pPr algn="ctr"/>
+            <a:endParaRPr/>
           </a:p>
         </p:txBody>
       </p:sp>
@@ -3671,7 +3693,7 @@
           <a:noFill/>
         </p:spPr>
         <p:txBody>
-          <a:bodyPr wrap="square" lIns="0" rIns="0" tIns="0" bIns="0">
+          <a:bodyPr wrap="square" lIns="0" tIns="0" rIns="0" bIns="0">
             <a:spAutoFit/>
           </a:bodyPr>
           <a:lstStyle/>
@@ -3692,14 +3714,14 @@
       </p:sp>
       <p:sp>
         <p:nvSpPr>
-          <p:cNvPr id="5" name="TextBox 4"/>
+          <p:cNvPr id="6" name="TextBox 5"/>
           <p:cNvSpPr txBox="1"/>
           <p:nvPr/>
         </p:nvSpPr>
         <p:spPr>
           <a:xfrm>
-            <a:off x="8412480" y="292608"/>
-            <a:ext cx="3154680" cy="320040"/>
+            <a:off x="640080" y="685800"/>
+            <a:ext cx="10927080" cy="640080"/>
           </a:xfrm>
           <a:prstGeom prst="rect">
             <a:avLst/>
@@ -3707,35 +3729,35 @@
           <a:noFill/>
         </p:spPr>
         <p:txBody>
-          <a:bodyPr wrap="square" lIns="0" rIns="0" tIns="0" bIns="0">
+          <a:bodyPr wrap="square" lIns="0" tIns="0" rIns="0" bIns="0">
             <a:spAutoFit/>
           </a:bodyPr>
           <a:lstStyle/>
           <a:p>
-            <a:pPr algn="r">
-              <a:defRPr sz="1200" b="1">
-                <a:solidFill>
-                  <a:srgbClr val="059669"/>
-                </a:solidFill>
-                <a:latin typeface="Segoe UI"/>
-              </a:defRPr>
-            </a:pPr>
-            <a:r>
-              <a:t>All pods running</a:t>
-            </a:r>
-          </a:p>
-        </p:txBody>
-      </p:sp>
-      <p:sp>
-        <p:nvSpPr>
-          <p:cNvPr id="6" name="TextBox 5"/>
+            <a:pPr algn="l">
+              <a:defRPr sz="2600" b="1">
+                <a:solidFill>
+                  <a:srgbClr val="0F172A"/>
+                </a:solidFill>
+                <a:latin typeface="Segoe UI"/>
+              </a:defRPr>
+            </a:pPr>
+            <a:r>
+              <a:t>Pods running on the cluster</a:t>
+            </a:r>
+          </a:p>
+        </p:txBody>
+      </p:sp>
+      <p:sp>
+        <p:nvSpPr>
+          <p:cNvPr id="7" name="TextBox 6"/>
           <p:cNvSpPr txBox="1"/>
           <p:nvPr/>
         </p:nvSpPr>
         <p:spPr>
           <a:xfrm>
-            <a:off x="640080" y="685800"/>
-            <a:ext cx="10927080" cy="640080"/>
+            <a:off x="640080" y="1417320"/>
+            <a:ext cx="10927080" cy="274320"/>
           </a:xfrm>
           <a:prstGeom prst="rect">
             <a:avLst/>
@@ -3743,48 +3765,12 @@
           <a:noFill/>
         </p:spPr>
         <p:txBody>
-          <a:bodyPr wrap="square" lIns="0" rIns="0" tIns="0" bIns="0">
+          <a:bodyPr wrap="square" lIns="0" tIns="0" rIns="0" bIns="0">
             <a:spAutoFit/>
           </a:bodyPr>
           <a:lstStyle/>
           <a:p>
             <a:pPr algn="l">
-              <a:defRPr sz="2600" b="1">
-                <a:solidFill>
-                  <a:srgbClr val="0F172A"/>
-                </a:solidFill>
-                <a:latin typeface="Segoe UI"/>
-              </a:defRPr>
-            </a:pPr>
-            <a:r>
-              <a:t>Pods running on the cluster</a:t>
-            </a:r>
-          </a:p>
-        </p:txBody>
-      </p:sp>
-      <p:sp>
-        <p:nvSpPr>
-          <p:cNvPr id="7" name="TextBox 6"/>
-          <p:cNvSpPr txBox="1"/>
-          <p:nvPr/>
-        </p:nvSpPr>
-        <p:spPr>
-          <a:xfrm>
-            <a:off x="640080" y="1417320"/>
-            <a:ext cx="10927080" cy="274320"/>
-          </a:xfrm>
-          <a:prstGeom prst="rect">
-            <a:avLst/>
-          </a:prstGeom>
-          <a:noFill/>
-        </p:spPr>
-        <p:txBody>
-          <a:bodyPr wrap="square" lIns="0" rIns="0" tIns="0" bIns="0">
-            <a:spAutoFit/>
-          </a:bodyPr>
-          <a:lstStyle/>
-          <a:p>
-            <a:pPr algn="l">
               <a:defRPr sz="1500" b="1">
                 <a:solidFill>
                   <a:srgbClr val="0284C7"/>
@@ -3815,7 +3801,7 @@
           <a:noFill/>
         </p:spPr>
         <p:txBody>
-          <a:bodyPr wrap="square" lIns="0" rIns="0" tIns="0" bIns="0">
+          <a:bodyPr wrap="square" lIns="0" tIns="0" rIns="0" bIns="0">
             <a:spAutoFit/>
           </a:bodyPr>
           <a:lstStyle/>
@@ -3867,7 +3853,7 @@
           <a:noFill/>
         </p:spPr>
         <p:txBody>
-          <a:bodyPr wrap="square" lIns="0" rIns="0" tIns="0" bIns="0">
+          <a:bodyPr wrap="square" lIns="0" tIns="0" rIns="0" bIns="0">
             <a:spAutoFit/>
           </a:bodyPr>
           <a:lstStyle/>
@@ -3947,6 +3933,7 @@
           <a:lstStyle/>
           <a:p>
             <a:pPr algn="ctr"/>
+            <a:endParaRPr/>
           </a:p>
         </p:txBody>
       </p:sp>
@@ -3974,42 +3961,6 @@
           </a:prstGeom>
         </p:spPr>
       </p:pic>
-      <p:sp>
-        <p:nvSpPr>
-          <p:cNvPr id="12" name="TextBox 11"/>
-          <p:cNvSpPr txBox="1"/>
-          <p:nvPr/>
-        </p:nvSpPr>
-        <p:spPr>
-          <a:xfrm>
-            <a:off x="640080" y="6309360"/>
-            <a:ext cx="10927080" cy="320040"/>
-          </a:xfrm>
-          <a:prstGeom prst="rect">
-            <a:avLst/>
-          </a:prstGeom>
-          <a:noFill/>
-        </p:spPr>
-        <p:txBody>
-          <a:bodyPr wrap="square" lIns="0" rIns="0" tIns="0" bIns="0">
-            <a:spAutoFit/>
-          </a:bodyPr>
-          <a:lstStyle/>
-          <a:p>
-            <a:pPr algn="l">
-              <a:defRPr sz="1000" b="0">
-                <a:solidFill>
-                  <a:srgbClr val="64748B"/>
-                </a:solidFill>
-                <a:latin typeface="Segoe UI"/>
-              </a:defRPr>
-            </a:pPr>
-            <a:r>
-              <a:t>screenshot/helm/terminal.png - kubectl output with pods running</a:t>
-            </a:r>
-          </a:p>
-        </p:txBody>
-      </p:sp>
     </p:spTree>
   </p:cSld>
   <p:clrMapOvr>
@@ -4019,7 +3970,7 @@
 </file>
 
 <file path=ppt/slides/slide11.xml><?xml version="1.0" encoding="utf-8"?>
-<p:sld xmlns:a="http://schemas.openxmlformats.org/drawingml/2006/main" xmlns:p="http://schemas.openxmlformats.org/presentationml/2006/main" xmlns:r="http://schemas.openxmlformats.org/officeDocument/2006/relationships">
+<p:sld xmlns:a="http://schemas.openxmlformats.org/drawingml/2006/main" xmlns:r="http://schemas.openxmlformats.org/officeDocument/2006/relationships" xmlns:p="http://schemas.openxmlformats.org/presentationml/2006/main">
   <p:cSld>
     <p:spTree>
       <p:nvGrpSpPr>
@@ -4027,7 +3978,14 @@
         <p:cNvGrpSpPr/>
         <p:nvPr/>
       </p:nvGrpSpPr>
-      <p:grpSpPr/>
+      <p:grpSpPr>
+        <a:xfrm>
+          <a:off x="0" y="0"/>
+          <a:ext cx="0" cy="0"/>
+          <a:chOff x="0" y="0"/>
+          <a:chExt cx="0" cy="0"/>
+        </a:xfrm>
+      </p:grpSpPr>
       <p:sp>
         <p:nvSpPr>
           <p:cNvPr id="2" name="Rectangle 1"/>
@@ -4069,6 +4027,7 @@
           <a:lstStyle/>
           <a:p>
             <a:pPr algn="ctr"/>
+            <a:endParaRPr/>
           </a:p>
         </p:txBody>
       </p:sp>
@@ -4113,6 +4072,7 @@
           <a:lstStyle/>
           <a:p>
             <a:pPr algn="ctr"/>
+            <a:endParaRPr/>
           </a:p>
         </p:txBody>
       </p:sp>
@@ -4133,7 +4093,7 @@
           <a:noFill/>
         </p:spPr>
         <p:txBody>
-          <a:bodyPr wrap="square" lIns="0" rIns="0" tIns="0" bIns="0">
+          <a:bodyPr wrap="square" lIns="0" tIns="0" rIns="0" bIns="0">
             <a:spAutoFit/>
           </a:bodyPr>
           <a:lstStyle/>
@@ -4154,42 +4114,6 @@
       </p:sp>
       <p:sp>
         <p:nvSpPr>
-          <p:cNvPr id="5" name="TextBox 4"/>
-          <p:cNvSpPr txBox="1"/>
-          <p:nvPr/>
-        </p:nvSpPr>
-        <p:spPr>
-          <a:xfrm>
-            <a:off x="8412480" y="292608"/>
-            <a:ext cx="3154680" cy="320040"/>
-          </a:xfrm>
-          <a:prstGeom prst="rect">
-            <a:avLst/>
-          </a:prstGeom>
-          <a:noFill/>
-        </p:spPr>
-        <p:txBody>
-          <a:bodyPr wrap="square" lIns="0" rIns="0" tIns="0" bIns="0">
-            <a:spAutoFit/>
-          </a:bodyPr>
-          <a:lstStyle/>
-          <a:p>
-            <a:pPr algn="r">
-              <a:defRPr sz="1200" b="1">
-                <a:solidFill>
-                  <a:srgbClr val="059669"/>
-                </a:solidFill>
-                <a:latin typeface="Segoe UI"/>
-              </a:defRPr>
-            </a:pPr>
-            <a:r>
-              <a:t>Target UP</a:t>
-            </a:r>
-          </a:p>
-        </p:txBody>
-      </p:sp>
-      <p:sp>
-        <p:nvSpPr>
           <p:cNvPr id="6" name="TextBox 5"/>
           <p:cNvSpPr txBox="1"/>
           <p:nvPr/>
@@ -4205,7 +4129,7 @@
           <a:noFill/>
         </p:spPr>
         <p:txBody>
-          <a:bodyPr wrap="square" lIns="0" rIns="0" tIns="0" bIns="0">
+          <a:bodyPr wrap="square" lIns="0" tIns="0" rIns="0" bIns="0">
             <a:spAutoFit/>
           </a:bodyPr>
           <a:lstStyle/>
@@ -4269,6 +4193,7 @@
           <a:lstStyle/>
           <a:p>
             <a:pPr algn="ctr"/>
+            <a:endParaRPr/>
           </a:p>
         </p:txBody>
       </p:sp>
@@ -4289,7 +4214,7 @@
           <a:noFill/>
         </p:spPr>
         <p:txBody>
-          <a:bodyPr wrap="square" lIns="0" rIns="0" tIns="0" bIns="0">
+          <a:bodyPr wrap="square" lIns="0" tIns="0" rIns="0" bIns="0">
             <a:spAutoFit/>
           </a:bodyPr>
           <a:lstStyle/>
@@ -4449,6 +4374,7 @@
           <a:lstStyle/>
           <a:p>
             <a:pPr algn="ctr"/>
+            <a:endParaRPr/>
           </a:p>
         </p:txBody>
       </p:sp>
@@ -4469,7 +4395,7 @@
           <a:noFill/>
         </p:spPr>
         <p:txBody>
-          <a:bodyPr wrap="square" lIns="0" rIns="0" tIns="0" bIns="0">
+          <a:bodyPr wrap="square" lIns="0" tIns="0" rIns="0" bIns="0">
             <a:spAutoFit/>
           </a:bodyPr>
           <a:lstStyle/>
@@ -4512,42 +4438,6 @@
           </a:prstGeom>
         </p:spPr>
       </p:pic>
-      <p:sp>
-        <p:nvSpPr>
-          <p:cNvPr id="12" name="TextBox 11"/>
-          <p:cNvSpPr txBox="1"/>
-          <p:nvPr/>
-        </p:nvSpPr>
-        <p:spPr>
-          <a:xfrm>
-            <a:off x="640080" y="6309360"/>
-            <a:ext cx="10927080" cy="320040"/>
-          </a:xfrm>
-          <a:prstGeom prst="rect">
-            <a:avLst/>
-          </a:prstGeom>
-          <a:noFill/>
-        </p:spPr>
-        <p:txBody>
-          <a:bodyPr wrap="square" lIns="0" rIns="0" tIns="0" bIns="0">
-            <a:spAutoFit/>
-          </a:bodyPr>
-          <a:lstStyle/>
-          <a:p>
-            <a:pPr algn="l">
-              <a:defRPr sz="1000" b="0">
-                <a:solidFill>
-                  <a:srgbClr val="64748B"/>
-                </a:solidFill>
-                <a:latin typeface="Segoe UI"/>
-              </a:defRPr>
-            </a:pPr>
-            <a:r>
-              <a:t>screenshot/monitor/prom.png - Prometheus targets page showing the app UP</a:t>
-            </a:r>
-          </a:p>
-        </p:txBody>
-      </p:sp>
     </p:spTree>
   </p:cSld>
   <p:clrMapOvr>
@@ -4557,7 +4447,7 @@
 </file>
 
 <file path=ppt/slides/slide12.xml><?xml version="1.0" encoding="utf-8"?>
-<p:sld xmlns:a="http://schemas.openxmlformats.org/drawingml/2006/main" xmlns:p="http://schemas.openxmlformats.org/presentationml/2006/main" xmlns:r="http://schemas.openxmlformats.org/officeDocument/2006/relationships">
+<p:sld xmlns:a="http://schemas.openxmlformats.org/drawingml/2006/main" xmlns:r="http://schemas.openxmlformats.org/officeDocument/2006/relationships" xmlns:p="http://schemas.openxmlformats.org/presentationml/2006/main">
   <p:cSld>
     <p:spTree>
       <p:nvGrpSpPr>
@@ -4565,7 +4455,14 @@
         <p:cNvGrpSpPr/>
         <p:nvPr/>
       </p:nvGrpSpPr>
-      <p:grpSpPr/>
+      <p:grpSpPr>
+        <a:xfrm>
+          <a:off x="0" y="0"/>
+          <a:ext cx="0" cy="0"/>
+          <a:chOff x="0" y="0"/>
+          <a:chExt cx="0" cy="0"/>
+        </a:xfrm>
+      </p:grpSpPr>
       <p:sp>
         <p:nvSpPr>
           <p:cNvPr id="2" name="Rectangle 1"/>
@@ -4607,6 +4504,7 @@
           <a:lstStyle/>
           <a:p>
             <a:pPr algn="ctr"/>
+            <a:endParaRPr/>
           </a:p>
         </p:txBody>
       </p:sp>
@@ -4651,6 +4549,7 @@
           <a:lstStyle/>
           <a:p>
             <a:pPr algn="ctr"/>
+            <a:endParaRPr/>
           </a:p>
         </p:txBody>
       </p:sp>
@@ -4671,7 +4570,7 @@
           <a:noFill/>
         </p:spPr>
         <p:txBody>
-          <a:bodyPr wrap="square" lIns="0" rIns="0" tIns="0" bIns="0">
+          <a:bodyPr wrap="square" lIns="0" tIns="0" rIns="0" bIns="0">
             <a:spAutoFit/>
           </a:bodyPr>
           <a:lstStyle/>
@@ -4692,14 +4591,14 @@
       </p:sp>
       <p:sp>
         <p:nvSpPr>
-          <p:cNvPr id="5" name="TextBox 4"/>
+          <p:cNvPr id="6" name="TextBox 5"/>
           <p:cNvSpPr txBox="1"/>
           <p:nvPr/>
         </p:nvSpPr>
         <p:spPr>
           <a:xfrm>
-            <a:off x="8412480" y="292608"/>
-            <a:ext cx="3154680" cy="320040"/>
+            <a:off x="640080" y="685800"/>
+            <a:ext cx="10927080" cy="640080"/>
           </a:xfrm>
           <a:prstGeom prst="rect">
             <a:avLst/>
@@ -4707,35 +4606,35 @@
           <a:noFill/>
         </p:spPr>
         <p:txBody>
-          <a:bodyPr wrap="square" lIns="0" rIns="0" tIns="0" bIns="0">
+          <a:bodyPr wrap="square" lIns="0" tIns="0" rIns="0" bIns="0">
             <a:spAutoFit/>
           </a:bodyPr>
           <a:lstStyle/>
           <a:p>
-            <a:pPr algn="r">
-              <a:defRPr sz="1200" b="1">
-                <a:solidFill>
-                  <a:srgbClr val="059669"/>
-                </a:solidFill>
-                <a:latin typeface="Segoe UI"/>
-              </a:defRPr>
-            </a:pPr>
-            <a:r>
-              <a:t>/metrics live</a:t>
-            </a:r>
-          </a:p>
-        </p:txBody>
-      </p:sp>
-      <p:sp>
-        <p:nvSpPr>
-          <p:cNvPr id="6" name="TextBox 5"/>
+            <a:pPr algn="l">
+              <a:defRPr sz="2600" b="1">
+                <a:solidFill>
+                  <a:srgbClr val="0F172A"/>
+                </a:solidFill>
+                <a:latin typeface="Segoe UI"/>
+              </a:defRPr>
+            </a:pPr>
+            <a:r>
+              <a:t>The metrics the app exposes</a:t>
+            </a:r>
+          </a:p>
+        </p:txBody>
+      </p:sp>
+      <p:sp>
+        <p:nvSpPr>
+          <p:cNvPr id="7" name="TextBox 6"/>
           <p:cNvSpPr txBox="1"/>
           <p:nvPr/>
         </p:nvSpPr>
         <p:spPr>
           <a:xfrm>
-            <a:off x="640080" y="685800"/>
-            <a:ext cx="10927080" cy="640080"/>
+            <a:off x="640080" y="1417320"/>
+            <a:ext cx="10927080" cy="274320"/>
           </a:xfrm>
           <a:prstGeom prst="rect">
             <a:avLst/>
@@ -4743,48 +4642,12 @@
           <a:noFill/>
         </p:spPr>
         <p:txBody>
-          <a:bodyPr wrap="square" lIns="0" rIns="0" tIns="0" bIns="0">
+          <a:bodyPr wrap="square" lIns="0" tIns="0" rIns="0" bIns="0">
             <a:spAutoFit/>
           </a:bodyPr>
           <a:lstStyle/>
           <a:p>
             <a:pPr algn="l">
-              <a:defRPr sz="2600" b="1">
-                <a:solidFill>
-                  <a:srgbClr val="0F172A"/>
-                </a:solidFill>
-                <a:latin typeface="Segoe UI"/>
-              </a:defRPr>
-            </a:pPr>
-            <a:r>
-              <a:t>The metrics the app exposes</a:t>
-            </a:r>
-          </a:p>
-        </p:txBody>
-      </p:sp>
-      <p:sp>
-        <p:nvSpPr>
-          <p:cNvPr id="7" name="TextBox 6"/>
-          <p:cNvSpPr txBox="1"/>
-          <p:nvPr/>
-        </p:nvSpPr>
-        <p:spPr>
-          <a:xfrm>
-            <a:off x="640080" y="1417320"/>
-            <a:ext cx="10927080" cy="274320"/>
-          </a:xfrm>
-          <a:prstGeom prst="rect">
-            <a:avLst/>
-          </a:prstGeom>
-          <a:noFill/>
-        </p:spPr>
-        <p:txBody>
-          <a:bodyPr wrap="square" lIns="0" rIns="0" tIns="0" bIns="0">
-            <a:spAutoFit/>
-          </a:bodyPr>
-          <a:lstStyle/>
-          <a:p>
-            <a:pPr algn="l">
               <a:defRPr sz="1500" b="1">
                 <a:solidFill>
                   <a:srgbClr val="0284C7"/>
@@ -4815,7 +4678,7 @@
           <a:noFill/>
         </p:spPr>
         <p:txBody>
-          <a:bodyPr wrap="square" lIns="0" rIns="0" tIns="0" bIns="0">
+          <a:bodyPr wrap="square" lIns="0" tIns="0" rIns="0" bIns="0">
             <a:spAutoFit/>
           </a:bodyPr>
           <a:lstStyle/>
@@ -4867,7 +4730,7 @@
           <a:noFill/>
         </p:spPr>
         <p:txBody>
-          <a:bodyPr wrap="square" lIns="0" rIns="0" tIns="0" bIns="0">
+          <a:bodyPr wrap="square" lIns="0" tIns="0" rIns="0" bIns="0">
             <a:spAutoFit/>
           </a:bodyPr>
           <a:lstStyle/>
@@ -4947,6 +4810,7 @@
           <a:lstStyle/>
           <a:p>
             <a:pPr algn="ctr"/>
+            <a:endParaRPr/>
           </a:p>
         </p:txBody>
       </p:sp>
@@ -4974,42 +4838,6 @@
           </a:prstGeom>
         </p:spPr>
       </p:pic>
-      <p:sp>
-        <p:nvSpPr>
-          <p:cNvPr id="12" name="TextBox 11"/>
-          <p:cNvSpPr txBox="1"/>
-          <p:nvPr/>
-        </p:nvSpPr>
-        <p:spPr>
-          <a:xfrm>
-            <a:off x="640080" y="6309360"/>
-            <a:ext cx="10927080" cy="320040"/>
-          </a:xfrm>
-          <a:prstGeom prst="rect">
-            <a:avLst/>
-          </a:prstGeom>
-          <a:noFill/>
-        </p:spPr>
-        <p:txBody>
-          <a:bodyPr wrap="square" lIns="0" rIns="0" tIns="0" bIns="0">
-            <a:spAutoFit/>
-          </a:bodyPr>
-          <a:lstStyle/>
-          <a:p>
-            <a:pPr algn="l">
-              <a:defRPr sz="1000" b="0">
-                <a:solidFill>
-                  <a:srgbClr val="64748B"/>
-                </a:solidFill>
-                <a:latin typeface="Segoe UI"/>
-              </a:defRPr>
-            </a:pPr>
-            <a:r>
-              <a:t>screenshot/monitor/image.png - raw Prometheus metrics from the backend</a:t>
-            </a:r>
-          </a:p>
-        </p:txBody>
-      </p:sp>
     </p:spTree>
   </p:cSld>
   <p:clrMapOvr>
@@ -5019,7 +4847,7 @@
 </file>
 
 <file path=ppt/slides/slide13.xml><?xml version="1.0" encoding="utf-8"?>
-<p:sld xmlns:a="http://schemas.openxmlformats.org/drawingml/2006/main" xmlns:p="http://schemas.openxmlformats.org/presentationml/2006/main" xmlns:r="http://schemas.openxmlformats.org/officeDocument/2006/relationships">
+<p:sld xmlns:a="http://schemas.openxmlformats.org/drawingml/2006/main" xmlns:r="http://schemas.openxmlformats.org/officeDocument/2006/relationships" xmlns:p="http://schemas.openxmlformats.org/presentationml/2006/main">
   <p:cSld>
     <p:spTree>
       <p:nvGrpSpPr>
@@ -5027,7 +4855,14 @@
         <p:cNvGrpSpPr/>
         <p:nvPr/>
       </p:nvGrpSpPr>
-      <p:grpSpPr/>
+      <p:grpSpPr>
+        <a:xfrm>
+          <a:off x="0" y="0"/>
+          <a:ext cx="0" cy="0"/>
+          <a:chOff x="0" y="0"/>
+          <a:chExt cx="0" cy="0"/>
+        </a:xfrm>
+      </p:grpSpPr>
       <p:sp>
         <p:nvSpPr>
           <p:cNvPr id="2" name="Rectangle 1"/>
@@ -5069,6 +4904,7 @@
           <a:lstStyle/>
           <a:p>
             <a:pPr algn="ctr"/>
+            <a:endParaRPr/>
           </a:p>
         </p:txBody>
       </p:sp>
@@ -5113,6 +4949,7 @@
           <a:lstStyle/>
           <a:p>
             <a:pPr algn="ctr"/>
+            <a:endParaRPr/>
           </a:p>
         </p:txBody>
       </p:sp>
@@ -5133,7 +4970,7 @@
           <a:noFill/>
         </p:spPr>
         <p:txBody>
-          <a:bodyPr wrap="square" lIns="0" rIns="0" tIns="0" bIns="0">
+          <a:bodyPr wrap="square" lIns="0" tIns="0" rIns="0" bIns="0">
             <a:spAutoFit/>
           </a:bodyPr>
           <a:lstStyle/>
@@ -5154,42 +4991,6 @@
       </p:sp>
       <p:sp>
         <p:nvSpPr>
-          <p:cNvPr id="5" name="TextBox 4"/>
-          <p:cNvSpPr txBox="1"/>
-          <p:nvPr/>
-        </p:nvSpPr>
-        <p:spPr>
-          <a:xfrm>
-            <a:off x="8412480" y="292608"/>
-            <a:ext cx="3154680" cy="320040"/>
-          </a:xfrm>
-          <a:prstGeom prst="rect">
-            <a:avLst/>
-          </a:prstGeom>
-          <a:noFill/>
-        </p:spPr>
-        <p:txBody>
-          <a:bodyPr wrap="square" lIns="0" rIns="0" tIns="0" bIns="0">
-            <a:spAutoFit/>
-          </a:bodyPr>
-          <a:lstStyle/>
-          <a:p>
-            <a:pPr algn="r">
-              <a:defRPr sz="1200" b="1">
-                <a:solidFill>
-                  <a:srgbClr val="059669"/>
-                </a:solidFill>
-                <a:latin typeface="Segoe UI"/>
-              </a:defRPr>
-            </a:pPr>
-            <a:r>
-              <a:t>100 / 100 points</a:t>
-            </a:r>
-          </a:p>
-        </p:txBody>
-      </p:sp>
-      <p:sp>
-        <p:nvSpPr>
           <p:cNvPr id="6" name="TextBox 5"/>
           <p:cNvSpPr txBox="1"/>
           <p:nvPr/>
@@ -5205,7 +5006,7 @@
           <a:noFill/>
         </p:spPr>
         <p:txBody>
-          <a:bodyPr wrap="square" lIns="0" rIns="0" tIns="0" bIns="0">
+          <a:bodyPr wrap="square" lIns="0" tIns="0" rIns="0" bIns="0">
             <a:spAutoFit/>
           </a:bodyPr>
           <a:lstStyle/>
@@ -5269,6 +5070,7 @@
           <a:lstStyle/>
           <a:p>
             <a:pPr algn="ctr"/>
+            <a:endParaRPr/>
           </a:p>
         </p:txBody>
       </p:sp>
@@ -5281,7 +5083,7 @@
         <p:spPr>
           <a:xfrm>
             <a:off x="868680" y="1536192"/>
-            <a:ext cx="1691640" cy="365760"/>
+            <a:ext cx="1691640" cy="369332"/>
           </a:xfrm>
           <a:prstGeom prst="rect">
             <a:avLst/>
@@ -5289,7 +5091,7 @@
           <a:noFill/>
         </p:spPr>
         <p:txBody>
-          <a:bodyPr wrap="square" lIns="0" rIns="0" tIns="0" bIns="0">
+          <a:bodyPr wrap="square" lIns="0" tIns="0" rIns="0" bIns="0" anchor="t">
             <a:spAutoFit/>
           </a:bodyPr>
           <a:lstStyle/>
@@ -5303,8 +5105,21 @@
               </a:defRPr>
             </a:pPr>
             <a:r>
-              <a:t>M1 (10 pts)</a:t>
-            </a:r>
+              <a:t>M1 </a:t>
+            </a:r>
+          </a:p>
+          <a:p>
+            <a:pPr>
+              <a:defRPr sz="1200" b="1">
+                <a:solidFill>
+                  <a:srgbClr val="0284C7"/>
+                </a:solidFill>
+                <a:latin typeface="Segoe UI"/>
+              </a:defRPr>
+            </a:pPr>
+            <a:endParaRPr lang="en-US" dirty="0">
+              <a:cs typeface="Segoe UI"/>
+            </a:endParaRPr>
           </a:p>
         </p:txBody>
       </p:sp>
@@ -5325,7 +5140,7 @@
           <a:noFill/>
         </p:spPr>
         <p:txBody>
-          <a:bodyPr wrap="square" lIns="0" rIns="0" tIns="0" bIns="0">
+          <a:bodyPr wrap="square" lIns="0" tIns="0" rIns="0" bIns="0">
             <a:spAutoFit/>
           </a:bodyPr>
           <a:lstStyle/>
@@ -5361,7 +5176,7 @@
           <a:noFill/>
         </p:spPr>
         <p:txBody>
-          <a:bodyPr wrap="square" lIns="0" rIns="0" tIns="0" bIns="0">
+          <a:bodyPr wrap="square" lIns="0" tIns="0" rIns="0" bIns="0">
             <a:spAutoFit/>
           </a:bodyPr>
           <a:lstStyle/>
@@ -5389,7 +5204,7 @@
         <p:spPr>
           <a:xfrm>
             <a:off x="868680" y="2048256"/>
-            <a:ext cx="1691640" cy="365760"/>
+            <a:ext cx="1691640" cy="184666"/>
           </a:xfrm>
           <a:prstGeom prst="rect">
             <a:avLst/>
@@ -5397,7 +5212,7 @@
           <a:noFill/>
         </p:spPr>
         <p:txBody>
-          <a:bodyPr wrap="square" lIns="0" rIns="0" tIns="0" bIns="0">
+          <a:bodyPr wrap="square" lIns="0" tIns="0" rIns="0" bIns="0" anchor="t">
             <a:spAutoFit/>
           </a:bodyPr>
           <a:lstStyle/>
@@ -5411,8 +5226,9 @@
               </a:defRPr>
             </a:pPr>
             <a:r>
-              <a:t>M2 (10 pts)</a:t>
-            </a:r>
+              <a:t>M2 </a:t>
+            </a:r>
+            <a:endParaRPr lang="en-US"/>
           </a:p>
         </p:txBody>
       </p:sp>
@@ -5433,7 +5249,7 @@
           <a:noFill/>
         </p:spPr>
         <p:txBody>
-          <a:bodyPr wrap="square" lIns="0" rIns="0" tIns="0" bIns="0">
+          <a:bodyPr wrap="square" lIns="0" tIns="0" rIns="0" bIns="0">
             <a:spAutoFit/>
           </a:bodyPr>
           <a:lstStyle/>
@@ -5469,7 +5285,7 @@
           <a:noFill/>
         </p:spPr>
         <p:txBody>
-          <a:bodyPr wrap="square" lIns="0" rIns="0" tIns="0" bIns="0">
+          <a:bodyPr wrap="square" lIns="0" tIns="0" rIns="0" bIns="0">
             <a:spAutoFit/>
           </a:bodyPr>
           <a:lstStyle/>
@@ -5533,6 +5349,7 @@
           <a:lstStyle/>
           <a:p>
             <a:pPr algn="ctr"/>
+            <a:endParaRPr/>
           </a:p>
         </p:txBody>
       </p:sp>
@@ -5545,7 +5362,7 @@
         <p:spPr>
           <a:xfrm>
             <a:off x="868680" y="2560320"/>
-            <a:ext cx="1691640" cy="365760"/>
+            <a:ext cx="1691640" cy="184666"/>
           </a:xfrm>
           <a:prstGeom prst="rect">
             <a:avLst/>
@@ -5553,7 +5370,7 @@
           <a:noFill/>
         </p:spPr>
         <p:txBody>
-          <a:bodyPr wrap="square" lIns="0" rIns="0" tIns="0" bIns="0">
+          <a:bodyPr wrap="square" lIns="0" tIns="0" rIns="0" bIns="0" anchor="t">
             <a:spAutoFit/>
           </a:bodyPr>
           <a:lstStyle/>
@@ -5567,7 +5384,7 @@
               </a:defRPr>
             </a:pPr>
             <a:r>
-              <a:t>M3 (5 pts)</a:t>
+              <a:t>M3 </a:t>
             </a:r>
           </a:p>
         </p:txBody>
@@ -5589,7 +5406,7 @@
           <a:noFill/>
         </p:spPr>
         <p:txBody>
-          <a:bodyPr wrap="square" lIns="0" rIns="0" tIns="0" bIns="0">
+          <a:bodyPr wrap="square" lIns="0" tIns="0" rIns="0" bIns="0">
             <a:spAutoFit/>
           </a:bodyPr>
           <a:lstStyle/>
@@ -5625,7 +5442,7 @@
           <a:noFill/>
         </p:spPr>
         <p:txBody>
-          <a:bodyPr wrap="square" lIns="0" rIns="0" tIns="0" bIns="0">
+          <a:bodyPr wrap="square" lIns="0" tIns="0" rIns="0" bIns="0">
             <a:spAutoFit/>
           </a:bodyPr>
           <a:lstStyle/>
@@ -5653,7 +5470,7 @@
         <p:spPr>
           <a:xfrm>
             <a:off x="868680" y="3072384"/>
-            <a:ext cx="1691640" cy="365760"/>
+            <a:ext cx="1691640" cy="184666"/>
           </a:xfrm>
           <a:prstGeom prst="rect">
             <a:avLst/>
@@ -5661,7 +5478,7 @@
           <a:noFill/>
         </p:spPr>
         <p:txBody>
-          <a:bodyPr wrap="square" lIns="0" rIns="0" tIns="0" bIns="0">
+          <a:bodyPr wrap="square" lIns="0" tIns="0" rIns="0" bIns="0" anchor="t">
             <a:spAutoFit/>
           </a:bodyPr>
           <a:lstStyle/>
@@ -5675,8 +5492,9 @@
               </a:defRPr>
             </a:pPr>
             <a:r>
-              <a:t>M4 (10 pts)</a:t>
-            </a:r>
+              <a:t>M4</a:t>
+            </a:r>
+            <a:endParaRPr lang="en-US"/>
           </a:p>
         </p:txBody>
       </p:sp>
@@ -5697,7 +5515,7 @@
           <a:noFill/>
         </p:spPr>
         <p:txBody>
-          <a:bodyPr wrap="square" lIns="0" rIns="0" tIns="0" bIns="0">
+          <a:bodyPr wrap="square" lIns="0" tIns="0" rIns="0" bIns="0">
             <a:spAutoFit/>
           </a:bodyPr>
           <a:lstStyle/>
@@ -5733,7 +5551,7 @@
           <a:noFill/>
         </p:spPr>
         <p:txBody>
-          <a:bodyPr wrap="square" lIns="0" rIns="0" tIns="0" bIns="0">
+          <a:bodyPr wrap="square" lIns="0" tIns="0" rIns="0" bIns="0">
             <a:spAutoFit/>
           </a:bodyPr>
           <a:lstStyle/>
@@ -5797,6 +5615,7 @@
           <a:lstStyle/>
           <a:p>
             <a:pPr algn="ctr"/>
+            <a:endParaRPr/>
           </a:p>
         </p:txBody>
       </p:sp>
@@ -5808,8 +5627,8 @@
         </p:nvSpPr>
         <p:spPr>
           <a:xfrm>
-            <a:off x="868680" y="3584448"/>
-            <a:ext cx="1691640" cy="365760"/>
+            <a:off x="868680" y="3542695"/>
+            <a:ext cx="1691640" cy="184666"/>
           </a:xfrm>
           <a:prstGeom prst="rect">
             <a:avLst/>
@@ -5817,7 +5636,7 @@
           <a:noFill/>
         </p:spPr>
         <p:txBody>
-          <a:bodyPr wrap="square" lIns="0" rIns="0" tIns="0" bIns="0">
+          <a:bodyPr wrap="square" lIns="0" tIns="0" rIns="0" bIns="0" anchor="t">
             <a:spAutoFit/>
           </a:bodyPr>
           <a:lstStyle/>
@@ -5831,7 +5650,7 @@
               </a:defRPr>
             </a:pPr>
             <a:r>
-              <a:t>M5+M6 (20 pts)</a:t>
+              <a:t>M5+M6 </a:t>
             </a:r>
           </a:p>
         </p:txBody>
@@ -5853,7 +5672,7 @@
           <a:noFill/>
         </p:spPr>
         <p:txBody>
-          <a:bodyPr wrap="square" lIns="0" rIns="0" tIns="0" bIns="0">
+          <a:bodyPr wrap="square" lIns="0" tIns="0" rIns="0" bIns="0">
             <a:spAutoFit/>
           </a:bodyPr>
           <a:lstStyle/>
@@ -5889,7 +5708,7 @@
           <a:noFill/>
         </p:spPr>
         <p:txBody>
-          <a:bodyPr wrap="square" lIns="0" rIns="0" tIns="0" bIns="0">
+          <a:bodyPr wrap="square" lIns="0" tIns="0" rIns="0" bIns="0">
             <a:spAutoFit/>
           </a:bodyPr>
           <a:lstStyle/>
@@ -5917,7 +5736,7 @@
         <p:spPr>
           <a:xfrm>
             <a:off x="868680" y="4096512"/>
-            <a:ext cx="1691640" cy="365760"/>
+            <a:ext cx="1691640" cy="184666"/>
           </a:xfrm>
           <a:prstGeom prst="rect">
             <a:avLst/>
@@ -5925,7 +5744,7 @@
           <a:noFill/>
         </p:spPr>
         <p:txBody>
-          <a:bodyPr wrap="square" lIns="0" rIns="0" tIns="0" bIns="0">
+          <a:bodyPr wrap="square" lIns="0" tIns="0" rIns="0" bIns="0" anchor="t">
             <a:spAutoFit/>
           </a:bodyPr>
           <a:lstStyle/>
@@ -5939,7 +5758,7 @@
               </a:defRPr>
             </a:pPr>
             <a:r>
-              <a:t>M7 (15 pts)</a:t>
+              <a:t>M7 </a:t>
             </a:r>
           </a:p>
         </p:txBody>
@@ -5961,7 +5780,7 @@
           <a:noFill/>
         </p:spPr>
         <p:txBody>
-          <a:bodyPr wrap="square" lIns="0" rIns="0" tIns="0" bIns="0">
+          <a:bodyPr wrap="square" lIns="0" tIns="0" rIns="0" bIns="0">
             <a:spAutoFit/>
           </a:bodyPr>
           <a:lstStyle/>
@@ -5997,7 +5816,7 @@
           <a:noFill/>
         </p:spPr>
         <p:txBody>
-          <a:bodyPr wrap="square" lIns="0" rIns="0" tIns="0" bIns="0">
+          <a:bodyPr wrap="square" lIns="0" tIns="0" rIns="0" bIns="0">
             <a:spAutoFit/>
           </a:bodyPr>
           <a:lstStyle/>
@@ -6061,6 +5880,7 @@
           <a:lstStyle/>
           <a:p>
             <a:pPr algn="ctr"/>
+            <a:endParaRPr/>
           </a:p>
         </p:txBody>
       </p:sp>
@@ -6073,7 +5893,7 @@
         <p:spPr>
           <a:xfrm>
             <a:off x="868680" y="4608576"/>
-            <a:ext cx="1691640" cy="365760"/>
+            <a:ext cx="1691640" cy="184666"/>
           </a:xfrm>
           <a:prstGeom prst="rect">
             <a:avLst/>
@@ -6081,7 +5901,7 @@
           <a:noFill/>
         </p:spPr>
         <p:txBody>
-          <a:bodyPr wrap="square" lIns="0" rIns="0" tIns="0" bIns="0">
+          <a:bodyPr wrap="square" lIns="0" tIns="0" rIns="0" bIns="0" anchor="t">
             <a:spAutoFit/>
           </a:bodyPr>
           <a:lstStyle/>
@@ -6095,7 +5915,7 @@
               </a:defRPr>
             </a:pPr>
             <a:r>
-              <a:t>M8 (15 pts)</a:t>
+              <a:t>M8 </a:t>
             </a:r>
           </a:p>
         </p:txBody>
@@ -6117,7 +5937,7 @@
           <a:noFill/>
         </p:spPr>
         <p:txBody>
-          <a:bodyPr wrap="square" lIns="0" rIns="0" tIns="0" bIns="0">
+          <a:bodyPr wrap="square" lIns="0" tIns="0" rIns="0" bIns="0">
             <a:spAutoFit/>
           </a:bodyPr>
           <a:lstStyle/>
@@ -6153,7 +5973,7 @@
           <a:noFill/>
         </p:spPr>
         <p:txBody>
-          <a:bodyPr wrap="square" lIns="0" rIns="0" tIns="0" bIns="0">
+          <a:bodyPr wrap="square" lIns="0" tIns="0" rIns="0" bIns="0">
             <a:spAutoFit/>
           </a:bodyPr>
           <a:lstStyle/>
@@ -6181,7 +6001,7 @@
         <p:spPr>
           <a:xfrm>
             <a:off x="868680" y="5120640"/>
-            <a:ext cx="1691640" cy="365760"/>
+            <a:ext cx="1691640" cy="184666"/>
           </a:xfrm>
           <a:prstGeom prst="rect">
             <a:avLst/>
@@ -6189,7 +6009,7 @@
           <a:noFill/>
         </p:spPr>
         <p:txBody>
-          <a:bodyPr wrap="square" lIns="0" rIns="0" tIns="0" bIns="0">
+          <a:bodyPr wrap="square" lIns="0" tIns="0" rIns="0" bIns="0" anchor="t">
             <a:spAutoFit/>
           </a:bodyPr>
           <a:lstStyle/>
@@ -6203,7 +6023,7 @@
               </a:defRPr>
             </a:pPr>
             <a:r>
-              <a:t>M9 (10 pts)</a:t>
+              <a:t>M9 </a:t>
             </a:r>
           </a:p>
         </p:txBody>
@@ -6225,7 +6045,7 @@
           <a:noFill/>
         </p:spPr>
         <p:txBody>
-          <a:bodyPr wrap="square" lIns="0" rIns="0" tIns="0" bIns="0">
+          <a:bodyPr wrap="square" lIns="0" tIns="0" rIns="0" bIns="0">
             <a:spAutoFit/>
           </a:bodyPr>
           <a:lstStyle/>
@@ -6261,7 +6081,7 @@
           <a:noFill/>
         </p:spPr>
         <p:txBody>
-          <a:bodyPr wrap="square" lIns="0" rIns="0" tIns="0" bIns="0">
+          <a:bodyPr wrap="square" lIns="0" tIns="0" rIns="0" bIns="0">
             <a:spAutoFit/>
           </a:bodyPr>
           <a:lstStyle/>
@@ -6325,6 +6145,7 @@
           <a:lstStyle/>
           <a:p>
             <a:pPr algn="ctr"/>
+            <a:endParaRPr/>
           </a:p>
         </p:txBody>
       </p:sp>
@@ -6337,7 +6158,7 @@
         <p:spPr>
           <a:xfrm>
             <a:off x="868680" y="5632704"/>
-            <a:ext cx="1691640" cy="365760"/>
+            <a:ext cx="1691640" cy="184666"/>
           </a:xfrm>
           <a:prstGeom prst="rect">
             <a:avLst/>
@@ -6345,7 +6166,7 @@
           <a:noFill/>
         </p:spPr>
         <p:txBody>
-          <a:bodyPr wrap="square" lIns="0" rIns="0" tIns="0" bIns="0">
+          <a:bodyPr wrap="square" lIns="0" tIns="0" rIns="0" bIns="0" anchor="t">
             <a:spAutoFit/>
           </a:bodyPr>
           <a:lstStyle/>
@@ -6359,7 +6180,7 @@
               </a:defRPr>
             </a:pPr>
             <a:r>
-              <a:t>M10 (5 pts)</a:t>
+              <a:t>M10</a:t>
             </a:r>
           </a:p>
         </p:txBody>
@@ -6381,7 +6202,7 @@
           <a:noFill/>
         </p:spPr>
         <p:txBody>
-          <a:bodyPr wrap="square" lIns="0" rIns="0" tIns="0" bIns="0">
+          <a:bodyPr wrap="square" lIns="0" tIns="0" rIns="0" bIns="0">
             <a:spAutoFit/>
           </a:bodyPr>
           <a:lstStyle/>
@@ -6417,7 +6238,7 @@
           <a:noFill/>
         </p:spPr>
         <p:txBody>
-          <a:bodyPr wrap="square" lIns="0" rIns="0" tIns="0" bIns="0">
+          <a:bodyPr wrap="square" lIns="0" tIns="0" rIns="0" bIns="0">
             <a:spAutoFit/>
           </a:bodyPr>
           <a:lstStyle/>
@@ -6432,42 +6253,6 @@
             </a:pPr>
             <a:r>
               <a:t>This deck</a:t>
-            </a:r>
-          </a:p>
-        </p:txBody>
-      </p:sp>
-      <p:sp>
-        <p:nvSpPr>
-          <p:cNvPr id="39" name="TextBox 38"/>
-          <p:cNvSpPr txBox="1"/>
-          <p:nvPr/>
-        </p:nvSpPr>
-        <p:spPr>
-          <a:xfrm>
-            <a:off x="640080" y="6126480"/>
-            <a:ext cx="10927080" cy="365760"/>
-          </a:xfrm>
-          <a:prstGeom prst="rect">
-            <a:avLst/>
-          </a:prstGeom>
-          <a:noFill/>
-        </p:spPr>
-        <p:txBody>
-          <a:bodyPr wrap="square" lIns="0" rIns="0" tIns="0" bIns="0">
-            <a:spAutoFit/>
-          </a:bodyPr>
-          <a:lstStyle/>
-          <a:p>
-            <a:pPr algn="ctr">
-              <a:defRPr sz="1200" b="1">
-                <a:solidFill>
-                  <a:srgbClr val="059669"/>
-                </a:solidFill>
-                <a:latin typeface="Segoe UI"/>
-              </a:defRPr>
-            </a:pPr>
-            <a:r>
-              <a:t>Every module above is backed by a real screenshot in this deck - no claims without proof.</a:t>
             </a:r>
           </a:p>
         </p:txBody>
@@ -6481,7 +6266,7 @@
 </file>
 
 <file path=ppt/slides/slide2.xml><?xml version="1.0" encoding="utf-8"?>
-<p:sld xmlns:a="http://schemas.openxmlformats.org/drawingml/2006/main" xmlns:p="http://schemas.openxmlformats.org/presentationml/2006/main" xmlns:r="http://schemas.openxmlformats.org/officeDocument/2006/relationships">
+<p:sld xmlns:a="http://schemas.openxmlformats.org/drawingml/2006/main" xmlns:r="http://schemas.openxmlformats.org/officeDocument/2006/relationships" xmlns:p="http://schemas.openxmlformats.org/presentationml/2006/main">
   <p:cSld>
     <p:spTree>
       <p:nvGrpSpPr>
@@ -6489,7 +6274,14 @@
         <p:cNvGrpSpPr/>
         <p:nvPr/>
       </p:nvGrpSpPr>
-      <p:grpSpPr/>
+      <p:grpSpPr>
+        <a:xfrm>
+          <a:off x="0" y="0"/>
+          <a:ext cx="0" cy="0"/>
+          <a:chOff x="0" y="0"/>
+          <a:chExt cx="0" cy="0"/>
+        </a:xfrm>
+      </p:grpSpPr>
       <p:sp>
         <p:nvSpPr>
           <p:cNvPr id="2" name="Rectangle 1"/>
@@ -6531,6 +6323,7 @@
           <a:lstStyle/>
           <a:p>
             <a:pPr algn="ctr"/>
+            <a:endParaRPr/>
           </a:p>
         </p:txBody>
       </p:sp>
@@ -6575,6 +6368,7 @@
           <a:lstStyle/>
           <a:p>
             <a:pPr algn="ctr"/>
+            <a:endParaRPr/>
           </a:p>
         </p:txBody>
       </p:sp>
@@ -6595,7 +6389,7 @@
           <a:noFill/>
         </p:spPr>
         <p:txBody>
-          <a:bodyPr wrap="square" lIns="0" rIns="0" tIns="0" bIns="0">
+          <a:bodyPr wrap="square" lIns="0" tIns="0" rIns="0" bIns="0">
             <a:spAutoFit/>
           </a:bodyPr>
           <a:lstStyle/>
@@ -6616,42 +6410,6 @@
       </p:sp>
       <p:sp>
         <p:nvSpPr>
-          <p:cNvPr id="5" name="TextBox 4"/>
-          <p:cNvSpPr txBox="1"/>
-          <p:nvPr/>
-        </p:nvSpPr>
-        <p:spPr>
-          <a:xfrm>
-            <a:off x="8412480" y="292608"/>
-            <a:ext cx="3154680" cy="320040"/>
-          </a:xfrm>
-          <a:prstGeom prst="rect">
-            <a:avLst/>
-          </a:prstGeom>
-          <a:noFill/>
-        </p:spPr>
-        <p:txBody>
-          <a:bodyPr wrap="square" lIns="0" rIns="0" tIns="0" bIns="0">
-            <a:spAutoFit/>
-          </a:bodyPr>
-          <a:lstStyle/>
-          <a:p>
-            <a:pPr algn="r">
-              <a:defRPr sz="1200" b="1">
-                <a:solidFill>
-                  <a:srgbClr val="059669"/>
-                </a:solidFill>
-                <a:latin typeface="Segoe UI"/>
-              </a:defRPr>
-            </a:pPr>
-            <a:r>
-              <a:t>Working - 10/10</a:t>
-            </a:r>
-          </a:p>
-        </p:txBody>
-      </p:sp>
-      <p:sp>
-        <p:nvSpPr>
           <p:cNvPr id="6" name="TextBox 5"/>
           <p:cNvSpPr txBox="1"/>
           <p:nvPr/>
@@ -6667,7 +6425,7 @@
           <a:noFill/>
         </p:spPr>
         <p:txBody>
-          <a:bodyPr wrap="square" lIns="0" rIns="0" tIns="0" bIns="0">
+          <a:bodyPr wrap="square" lIns="0" tIns="0" rIns="0" bIns="0">
             <a:spAutoFit/>
           </a:bodyPr>
           <a:lstStyle/>
@@ -6731,6 +6489,7 @@
           <a:lstStyle/>
           <a:p>
             <a:pPr algn="ctr"/>
+            <a:endParaRPr/>
           </a:p>
         </p:txBody>
       </p:sp>
@@ -6751,7 +6510,7 @@
           <a:noFill/>
         </p:spPr>
         <p:txBody>
-          <a:bodyPr wrap="square" lIns="0" rIns="0" tIns="0" bIns="0">
+          <a:bodyPr wrap="square" lIns="0" tIns="0" rIns="0" bIns="0">
             <a:spAutoFit/>
           </a:bodyPr>
           <a:lstStyle/>
@@ -6911,6 +6670,7 @@
           <a:lstStyle/>
           <a:p>
             <a:pPr algn="ctr"/>
+            <a:endParaRPr/>
           </a:p>
         </p:txBody>
       </p:sp>
@@ -6931,7 +6691,7 @@
           <a:noFill/>
         </p:spPr>
         <p:txBody>
-          <a:bodyPr wrap="square" lIns="0" rIns="0" tIns="0" bIns="0">
+          <a:bodyPr wrap="square" lIns="0" tIns="0" rIns="0" bIns="0">
             <a:spAutoFit/>
           </a:bodyPr>
           <a:lstStyle/>
@@ -6974,42 +6734,6 @@
           </a:prstGeom>
         </p:spPr>
       </p:pic>
-      <p:sp>
-        <p:nvSpPr>
-          <p:cNvPr id="12" name="TextBox 11"/>
-          <p:cNvSpPr txBox="1"/>
-          <p:nvPr/>
-        </p:nvSpPr>
-        <p:spPr>
-          <a:xfrm>
-            <a:off x="640080" y="6309360"/>
-            <a:ext cx="10927080" cy="320040"/>
-          </a:xfrm>
-          <a:prstGeom prst="rect">
-            <a:avLst/>
-          </a:prstGeom>
-          <a:noFill/>
-        </p:spPr>
-        <p:txBody>
-          <a:bodyPr wrap="square" lIns="0" rIns="0" tIns="0" bIns="0">
-            <a:spAutoFit/>
-          </a:bodyPr>
-          <a:lstStyle/>
-          <a:p>
-            <a:pPr algn="l">
-              <a:defRPr sz="1000" b="0">
-                <a:solidFill>
-                  <a:srgbClr val="64748B"/>
-                </a:solidFill>
-                <a:latin typeface="Segoe UI"/>
-              </a:defRPr>
-            </a:pPr>
-            <a:r>
-              <a:t>screenshot/docker/browser.png - the running StockPulse dashboard in a real browser</a:t>
-            </a:r>
-          </a:p>
-        </p:txBody>
-      </p:sp>
     </p:spTree>
   </p:cSld>
   <p:clrMapOvr>
@@ -7019,7 +6743,7 @@
 </file>
 
 <file path=ppt/slides/slide3.xml><?xml version="1.0" encoding="utf-8"?>
-<p:sld xmlns:a="http://schemas.openxmlformats.org/drawingml/2006/main" xmlns:p="http://schemas.openxmlformats.org/presentationml/2006/main" xmlns:r="http://schemas.openxmlformats.org/officeDocument/2006/relationships">
+<p:sld xmlns:a="http://schemas.openxmlformats.org/drawingml/2006/main" xmlns:r="http://schemas.openxmlformats.org/officeDocument/2006/relationships" xmlns:p="http://schemas.openxmlformats.org/presentationml/2006/main">
   <p:cSld>
     <p:spTree>
       <p:nvGrpSpPr>
@@ -7027,7 +6751,14 @@
         <p:cNvGrpSpPr/>
         <p:nvPr/>
       </p:nvGrpSpPr>
-      <p:grpSpPr/>
+      <p:grpSpPr>
+        <a:xfrm>
+          <a:off x="0" y="0"/>
+          <a:ext cx="0" cy="0"/>
+          <a:chOff x="0" y="0"/>
+          <a:chExt cx="0" cy="0"/>
+        </a:xfrm>
+      </p:grpSpPr>
       <p:sp>
         <p:nvSpPr>
           <p:cNvPr id="2" name="Rectangle 1"/>
@@ -7069,6 +6800,7 @@
           <a:lstStyle/>
           <a:p>
             <a:pPr algn="ctr"/>
+            <a:endParaRPr/>
           </a:p>
         </p:txBody>
       </p:sp>
@@ -7113,6 +6845,7 @@
           <a:lstStyle/>
           <a:p>
             <a:pPr algn="ctr"/>
+            <a:endParaRPr/>
           </a:p>
         </p:txBody>
       </p:sp>
@@ -7133,7 +6866,7 @@
           <a:noFill/>
         </p:spPr>
         <p:txBody>
-          <a:bodyPr wrap="square" lIns="0" rIns="0" tIns="0" bIns="0">
+          <a:bodyPr wrap="square" lIns="0" tIns="0" rIns="0" bIns="0">
             <a:spAutoFit/>
           </a:bodyPr>
           <a:lstStyle/>
@@ -7154,42 +6887,6 @@
       </p:sp>
       <p:sp>
         <p:nvSpPr>
-          <p:cNvPr id="5" name="TextBox 4"/>
-          <p:cNvSpPr txBox="1"/>
-          <p:nvPr/>
-        </p:nvSpPr>
-        <p:spPr>
-          <a:xfrm>
-            <a:off x="8412480" y="292608"/>
-            <a:ext cx="3154680" cy="320040"/>
-          </a:xfrm>
-          <a:prstGeom prst="rect">
-            <a:avLst/>
-          </a:prstGeom>
-          <a:noFill/>
-        </p:spPr>
-        <p:txBody>
-          <a:bodyPr wrap="square" lIns="0" rIns="0" tIns="0" bIns="0">
-            <a:spAutoFit/>
-          </a:bodyPr>
-          <a:lstStyle/>
-          <a:p>
-            <a:pPr algn="r">
-              <a:defRPr sz="1200" b="1">
-                <a:solidFill>
-                  <a:srgbClr val="059669"/>
-                </a:solidFill>
-                <a:latin typeface="Segoe UI"/>
-              </a:defRPr>
-            </a:pPr>
-            <a:r>
-              <a:t>Working - 6 endpoints</a:t>
-            </a:r>
-          </a:p>
-        </p:txBody>
-      </p:sp>
-      <p:sp>
-        <p:nvSpPr>
           <p:cNvPr id="6" name="TextBox 5"/>
           <p:cNvSpPr txBox="1"/>
           <p:nvPr/>
@@ -7205,7 +6902,7 @@
           <a:noFill/>
         </p:spPr>
         <p:txBody>
-          <a:bodyPr wrap="square" lIns="0" rIns="0" tIns="0" bIns="0">
+          <a:bodyPr wrap="square" lIns="0" tIns="0" rIns="0" bIns="0">
             <a:spAutoFit/>
           </a:bodyPr>
           <a:lstStyle/>
@@ -7269,6 +6966,7 @@
           <a:lstStyle/>
           <a:p>
             <a:pPr algn="ctr"/>
+            <a:endParaRPr/>
           </a:p>
         </p:txBody>
       </p:sp>
@@ -7289,7 +6987,7 @@
           <a:noFill/>
         </p:spPr>
         <p:txBody>
-          <a:bodyPr wrap="square" lIns="0" rIns="0" tIns="0" bIns="0">
+          <a:bodyPr wrap="square" lIns="0" tIns="0" rIns="0" bIns="0">
             <a:spAutoFit/>
           </a:bodyPr>
           <a:lstStyle/>
@@ -7449,6 +7147,7 @@
           <a:lstStyle/>
           <a:p>
             <a:pPr algn="ctr"/>
+            <a:endParaRPr/>
           </a:p>
         </p:txBody>
       </p:sp>
@@ -7469,7 +7168,7 @@
           <a:noFill/>
         </p:spPr>
         <p:txBody>
-          <a:bodyPr wrap="square" lIns="0" rIns="0" tIns="0" bIns="0">
+          <a:bodyPr wrap="square" lIns="0" tIns="0" rIns="0" bIns="0">
             <a:spAutoFit/>
           </a:bodyPr>
           <a:lstStyle/>
@@ -7512,42 +7211,6 @@
           </a:prstGeom>
         </p:spPr>
       </p:pic>
-      <p:sp>
-        <p:nvSpPr>
-          <p:cNvPr id="12" name="TextBox 11"/>
-          <p:cNvSpPr txBox="1"/>
-          <p:nvPr/>
-        </p:nvSpPr>
-        <p:spPr>
-          <a:xfrm>
-            <a:off x="640080" y="6309360"/>
-            <a:ext cx="10927080" cy="320040"/>
-          </a:xfrm>
-          <a:prstGeom prst="rect">
-            <a:avLst/>
-          </a:prstGeom>
-          <a:noFill/>
-        </p:spPr>
-        <p:txBody>
-          <a:bodyPr wrap="square" lIns="0" rIns="0" tIns="0" bIns="0">
-            <a:spAutoFit/>
-          </a:bodyPr>
-          <a:lstStyle/>
-          <a:p>
-            <a:pPr algn="l">
-              <a:defRPr sz="1000" b="0">
-                <a:solidFill>
-                  <a:srgbClr val="64748B"/>
-                </a:solidFill>
-                <a:latin typeface="Segoe UI"/>
-              </a:defRPr>
-            </a:pPr>
-            <a:r>
-              <a:t>screenshot/docker/browser-doc.png - Swagger UI listing every API endpoint</a:t>
-            </a:r>
-          </a:p>
-        </p:txBody>
-      </p:sp>
     </p:spTree>
   </p:cSld>
   <p:clrMapOvr>
@@ -7557,7 +7220,7 @@
 </file>
 
 <file path=ppt/slides/slide4.xml><?xml version="1.0" encoding="utf-8"?>
-<p:sld xmlns:a="http://schemas.openxmlformats.org/drawingml/2006/main" xmlns:p="http://schemas.openxmlformats.org/presentationml/2006/main" xmlns:r="http://schemas.openxmlformats.org/officeDocument/2006/relationships">
+<p:sld xmlns:a="http://schemas.openxmlformats.org/drawingml/2006/main" xmlns:r="http://schemas.openxmlformats.org/officeDocument/2006/relationships" xmlns:p="http://schemas.openxmlformats.org/presentationml/2006/main">
   <p:cSld>
     <p:spTree>
       <p:nvGrpSpPr>
@@ -7565,7 +7228,14 @@
         <p:cNvGrpSpPr/>
         <p:nvPr/>
       </p:nvGrpSpPr>
-      <p:grpSpPr/>
+      <p:grpSpPr>
+        <a:xfrm>
+          <a:off x="0" y="0"/>
+          <a:ext cx="0" cy="0"/>
+          <a:chOff x="0" y="0"/>
+          <a:chExt cx="0" cy="0"/>
+        </a:xfrm>
+      </p:grpSpPr>
       <p:sp>
         <p:nvSpPr>
           <p:cNvPr id="2" name="Rectangle 1"/>
@@ -7607,6 +7277,7 @@
           <a:lstStyle/>
           <a:p>
             <a:pPr algn="ctr"/>
+            <a:endParaRPr/>
           </a:p>
         </p:txBody>
       </p:sp>
@@ -7651,6 +7322,7 @@
           <a:lstStyle/>
           <a:p>
             <a:pPr algn="ctr"/>
+            <a:endParaRPr/>
           </a:p>
         </p:txBody>
       </p:sp>
@@ -7671,7 +7343,7 @@
           <a:noFill/>
         </p:spPr>
         <p:txBody>
-          <a:bodyPr wrap="square" lIns="0" rIns="0" tIns="0" bIns="0">
+          <a:bodyPr wrap="square" lIns="0" tIns="0" rIns="0" bIns="0">
             <a:spAutoFit/>
           </a:bodyPr>
           <a:lstStyle/>
@@ -7692,42 +7364,6 @@
       </p:sp>
       <p:sp>
         <p:nvSpPr>
-          <p:cNvPr id="5" name="TextBox 4"/>
-          <p:cNvSpPr txBox="1"/>
-          <p:nvPr/>
-        </p:nvSpPr>
-        <p:spPr>
-          <a:xfrm>
-            <a:off x="8412480" y="292608"/>
-            <a:ext cx="3154680" cy="320040"/>
-          </a:xfrm>
-          <a:prstGeom prst="rect">
-            <a:avLst/>
-          </a:prstGeom>
-          <a:noFill/>
-        </p:spPr>
-        <p:txBody>
-          <a:bodyPr wrap="square" lIns="0" rIns="0" tIns="0" bIns="0">
-            <a:spAutoFit/>
-          </a:bodyPr>
-          <a:lstStyle/>
-          <a:p>
-            <a:pPr algn="r">
-              <a:defRPr sz="1200" b="1">
-                <a:solidFill>
-                  <a:srgbClr val="059669"/>
-                </a:solidFill>
-                <a:latin typeface="Segoe UI"/>
-              </a:defRPr>
-            </a:pPr>
-            <a:r>
-              <a:t>8/8 tests passed</a:t>
-            </a:r>
-          </a:p>
-        </p:txBody>
-      </p:sp>
-      <p:sp>
-        <p:nvSpPr>
           <p:cNvPr id="6" name="TextBox 5"/>
           <p:cNvSpPr txBox="1"/>
           <p:nvPr/>
@@ -7743,7 +7379,7 @@
           <a:noFill/>
         </p:spPr>
         <p:txBody>
-          <a:bodyPr wrap="square" lIns="0" rIns="0" tIns="0" bIns="0">
+          <a:bodyPr wrap="square" lIns="0" tIns="0" rIns="0" bIns="0">
             <a:spAutoFit/>
           </a:bodyPr>
           <a:lstStyle/>
@@ -7807,6 +7443,7 @@
           <a:lstStyle/>
           <a:p>
             <a:pPr algn="ctr"/>
+            <a:endParaRPr/>
           </a:p>
         </p:txBody>
       </p:sp>
@@ -7827,7 +7464,7 @@
           <a:noFill/>
         </p:spPr>
         <p:txBody>
-          <a:bodyPr wrap="square" lIns="0" rIns="0" tIns="0" bIns="0">
+          <a:bodyPr wrap="square" lIns="0" tIns="0" rIns="0" bIns="0">
             <a:spAutoFit/>
           </a:bodyPr>
           <a:lstStyle/>
@@ -7987,6 +7624,7 @@
           <a:lstStyle/>
           <a:p>
             <a:pPr algn="ctr"/>
+            <a:endParaRPr/>
           </a:p>
         </p:txBody>
       </p:sp>
@@ -8007,7 +7645,7 @@
           <a:noFill/>
         </p:spPr>
         <p:txBody>
-          <a:bodyPr wrap="square" lIns="0" rIns="0" tIns="0" bIns="0">
+          <a:bodyPr wrap="square" lIns="0" tIns="0" rIns="0" bIns="0">
             <a:spAutoFit/>
           </a:bodyPr>
           <a:lstStyle/>
@@ -8050,42 +7688,6 @@
           </a:prstGeom>
         </p:spPr>
       </p:pic>
-      <p:sp>
-        <p:nvSpPr>
-          <p:cNvPr id="12" name="TextBox 11"/>
-          <p:cNvSpPr txBox="1"/>
-          <p:nvPr/>
-        </p:nvSpPr>
-        <p:spPr>
-          <a:xfrm>
-            <a:off x="640080" y="6309360"/>
-            <a:ext cx="10927080" cy="320040"/>
-          </a:xfrm>
-          <a:prstGeom prst="rect">
-            <a:avLst/>
-          </a:prstGeom>
-          <a:noFill/>
-        </p:spPr>
-        <p:txBody>
-          <a:bodyPr wrap="square" lIns="0" rIns="0" tIns="0" bIns="0">
-            <a:spAutoFit/>
-          </a:bodyPr>
-          <a:lstStyle/>
-          <a:p>
-            <a:pPr algn="l">
-              <a:defRPr sz="1000" b="0">
-                <a:solidFill>
-                  <a:srgbClr val="64748B"/>
-                </a:solidFill>
-                <a:latin typeface="Segoe UI"/>
-              </a:defRPr>
-            </a:pPr>
-            <a:r>
-              <a:t>screenshot/pytest/image.png - terminal output showing 8 tests passing</a:t>
-            </a:r>
-          </a:p>
-        </p:txBody>
-      </p:sp>
     </p:spTree>
   </p:cSld>
   <p:clrMapOvr>
@@ -8095,7 +7697,7 @@
 </file>
 
 <file path=ppt/slides/slide5.xml><?xml version="1.0" encoding="utf-8"?>
-<p:sld xmlns:a="http://schemas.openxmlformats.org/drawingml/2006/main" xmlns:p="http://schemas.openxmlformats.org/presentationml/2006/main" xmlns:r="http://schemas.openxmlformats.org/officeDocument/2006/relationships">
+<p:sld xmlns:a="http://schemas.openxmlformats.org/drawingml/2006/main" xmlns:r="http://schemas.openxmlformats.org/officeDocument/2006/relationships" xmlns:p="http://schemas.openxmlformats.org/presentationml/2006/main">
   <p:cSld>
     <p:spTree>
       <p:nvGrpSpPr>
@@ -8103,7 +7705,14 @@
         <p:cNvGrpSpPr/>
         <p:nvPr/>
       </p:nvGrpSpPr>
-      <p:grpSpPr/>
+      <p:grpSpPr>
+        <a:xfrm>
+          <a:off x="0" y="0"/>
+          <a:ext cx="0" cy="0"/>
+          <a:chOff x="0" y="0"/>
+          <a:chExt cx="0" cy="0"/>
+        </a:xfrm>
+      </p:grpSpPr>
       <p:sp>
         <p:nvSpPr>
           <p:cNvPr id="2" name="Rectangle 1"/>
@@ -8145,6 +7754,7 @@
           <a:lstStyle/>
           <a:p>
             <a:pPr algn="ctr"/>
+            <a:endParaRPr/>
           </a:p>
         </p:txBody>
       </p:sp>
@@ -8189,6 +7799,7 @@
           <a:lstStyle/>
           <a:p>
             <a:pPr algn="ctr"/>
+            <a:endParaRPr/>
           </a:p>
         </p:txBody>
       </p:sp>
@@ -8209,7 +7820,7 @@
           <a:noFill/>
         </p:spPr>
         <p:txBody>
-          <a:bodyPr wrap="square" lIns="0" rIns="0" tIns="0" bIns="0">
+          <a:bodyPr wrap="square" lIns="0" tIns="0" rIns="0" bIns="0">
             <a:spAutoFit/>
           </a:bodyPr>
           <a:lstStyle/>
@@ -8230,42 +7841,6 @@
       </p:sp>
       <p:sp>
         <p:nvSpPr>
-          <p:cNvPr id="5" name="TextBox 4"/>
-          <p:cNvSpPr txBox="1"/>
-          <p:nvPr/>
-        </p:nvSpPr>
-        <p:spPr>
-          <a:xfrm>
-            <a:off x="8412480" y="292608"/>
-            <a:ext cx="3154680" cy="320040"/>
-          </a:xfrm>
-          <a:prstGeom prst="rect">
-            <a:avLst/>
-          </a:prstGeom>
-          <a:noFill/>
-        </p:spPr>
-        <p:txBody>
-          <a:bodyPr wrap="square" lIns="0" rIns="0" tIns="0" bIns="0">
-            <a:spAutoFit/>
-          </a:bodyPr>
-          <a:lstStyle/>
-          <a:p>
-            <a:pPr algn="r">
-              <a:defRPr sz="1200" b="1">
-                <a:solidFill>
-                  <a:srgbClr val="059669"/>
-                </a:solidFill>
-                <a:latin typeface="Segoe UI"/>
-              </a:defRPr>
-            </a:pPr>
-            <a:r>
-              <a:t>Public repo</a:t>
-            </a:r>
-          </a:p>
-        </p:txBody>
-      </p:sp>
-      <p:sp>
-        <p:nvSpPr>
           <p:cNvPr id="6" name="TextBox 5"/>
           <p:cNvSpPr txBox="1"/>
           <p:nvPr/>
@@ -8281,7 +7856,7 @@
           <a:noFill/>
         </p:spPr>
         <p:txBody>
-          <a:bodyPr wrap="square" lIns="0" rIns="0" tIns="0" bIns="0">
+          <a:bodyPr wrap="square" lIns="0" tIns="0" rIns="0" bIns="0">
             <a:spAutoFit/>
           </a:bodyPr>
           <a:lstStyle/>
@@ -8345,6 +7920,7 @@
           <a:lstStyle/>
           <a:p>
             <a:pPr algn="ctr"/>
+            <a:endParaRPr/>
           </a:p>
         </p:txBody>
       </p:sp>
@@ -8365,7 +7941,7 @@
           <a:noFill/>
         </p:spPr>
         <p:txBody>
-          <a:bodyPr wrap="square" lIns="0" rIns="0" tIns="0" bIns="0">
+          <a:bodyPr wrap="square" lIns="0" tIns="0" rIns="0" bIns="0">
             <a:spAutoFit/>
           </a:bodyPr>
           <a:lstStyle/>
@@ -8525,6 +8101,7 @@
           <a:lstStyle/>
           <a:p>
             <a:pPr algn="ctr"/>
+            <a:endParaRPr/>
           </a:p>
         </p:txBody>
       </p:sp>
@@ -8545,7 +8122,7 @@
           <a:noFill/>
         </p:spPr>
         <p:txBody>
-          <a:bodyPr wrap="square" lIns="0" rIns="0" tIns="0" bIns="0">
+          <a:bodyPr wrap="square" lIns="0" tIns="0" rIns="0" bIns="0">
             <a:spAutoFit/>
           </a:bodyPr>
           <a:lstStyle/>
@@ -8588,42 +8165,6 @@
           </a:prstGeom>
         </p:spPr>
       </p:pic>
-      <p:sp>
-        <p:nvSpPr>
-          <p:cNvPr id="12" name="TextBox 11"/>
-          <p:cNvSpPr txBox="1"/>
-          <p:nvPr/>
-        </p:nvSpPr>
-        <p:spPr>
-          <a:xfrm>
-            <a:off x="640080" y="6309360"/>
-            <a:ext cx="10927080" cy="320040"/>
-          </a:xfrm>
-          <a:prstGeom prst="rect">
-            <a:avLst/>
-          </a:prstGeom>
-          <a:noFill/>
-        </p:spPr>
-        <p:txBody>
-          <a:bodyPr wrap="square" lIns="0" rIns="0" tIns="0" bIns="0">
-            <a:spAutoFit/>
-          </a:bodyPr>
-          <a:lstStyle/>
-          <a:p>
-            <a:pPr algn="l">
-              <a:defRPr sz="1000" b="0">
-                <a:solidFill>
-                  <a:srgbClr val="64748B"/>
-                </a:solidFill>
-                <a:latin typeface="Segoe UI"/>
-              </a:defRPr>
-            </a:pPr>
-            <a:r>
-              <a:t>screenshot/Github/commits.png - commit history on GitHub</a:t>
-            </a:r>
-          </a:p>
-        </p:txBody>
-      </p:sp>
     </p:spTree>
   </p:cSld>
   <p:clrMapOvr>
@@ -8633,7 +8174,7 @@
 </file>
 
 <file path=ppt/slides/slide6.xml><?xml version="1.0" encoding="utf-8"?>
-<p:sld xmlns:a="http://schemas.openxmlformats.org/drawingml/2006/main" xmlns:p="http://schemas.openxmlformats.org/presentationml/2006/main" xmlns:r="http://schemas.openxmlformats.org/officeDocument/2006/relationships">
+<p:sld xmlns:a="http://schemas.openxmlformats.org/drawingml/2006/main" xmlns:r="http://schemas.openxmlformats.org/officeDocument/2006/relationships" xmlns:p="http://schemas.openxmlformats.org/presentationml/2006/main">
   <p:cSld>
     <p:spTree>
       <p:nvGrpSpPr>
@@ -8641,7 +8182,14 @@
         <p:cNvGrpSpPr/>
         <p:nvPr/>
       </p:nvGrpSpPr>
-      <p:grpSpPr/>
+      <p:grpSpPr>
+        <a:xfrm>
+          <a:off x="0" y="0"/>
+          <a:ext cx="0" cy="0"/>
+          <a:chOff x="0" y="0"/>
+          <a:chExt cx="0" cy="0"/>
+        </a:xfrm>
+      </p:grpSpPr>
       <p:sp>
         <p:nvSpPr>
           <p:cNvPr id="2" name="Rectangle 1"/>
@@ -8683,6 +8231,7 @@
           <a:lstStyle/>
           <a:p>
             <a:pPr algn="ctr"/>
+            <a:endParaRPr/>
           </a:p>
         </p:txBody>
       </p:sp>
@@ -8727,6 +8276,7 @@
           <a:lstStyle/>
           <a:p>
             <a:pPr algn="ctr"/>
+            <a:endParaRPr/>
           </a:p>
         </p:txBody>
       </p:sp>
@@ -8747,7 +8297,7 @@
           <a:noFill/>
         </p:spPr>
         <p:txBody>
-          <a:bodyPr wrap="square" lIns="0" rIns="0" tIns="0" bIns="0">
+          <a:bodyPr wrap="square" lIns="0" tIns="0" rIns="0" bIns="0">
             <a:spAutoFit/>
           </a:bodyPr>
           <a:lstStyle/>
@@ -8768,14 +8318,14 @@
       </p:sp>
       <p:sp>
         <p:nvSpPr>
-          <p:cNvPr id="5" name="TextBox 4"/>
+          <p:cNvPr id="6" name="TextBox 5"/>
           <p:cNvSpPr txBox="1"/>
           <p:nvPr/>
         </p:nvSpPr>
         <p:spPr>
           <a:xfrm>
-            <a:off x="8412480" y="292608"/>
-            <a:ext cx="3154680" cy="320040"/>
+            <a:off x="640080" y="685800"/>
+            <a:ext cx="10927080" cy="640080"/>
           </a:xfrm>
           <a:prstGeom prst="rect">
             <a:avLst/>
@@ -8783,35 +8333,35 @@
           <a:noFill/>
         </p:spPr>
         <p:txBody>
-          <a:bodyPr wrap="square" lIns="0" rIns="0" tIns="0" bIns="0">
+          <a:bodyPr wrap="square" lIns="0" tIns="0" rIns="0" bIns="0">
             <a:spAutoFit/>
           </a:bodyPr>
           <a:lstStyle/>
           <a:p>
-            <a:pPr algn="r">
-              <a:defRPr sz="1200" b="1">
-                <a:solidFill>
-                  <a:srgbClr val="059669"/>
-                </a:solidFill>
-                <a:latin typeface="Segoe UI"/>
-              </a:defRPr>
-            </a:pPr>
-            <a:r>
-              <a:t>3 services up</a:t>
-            </a:r>
-          </a:p>
-        </p:txBody>
-      </p:sp>
-      <p:sp>
-        <p:nvSpPr>
-          <p:cNvPr id="6" name="TextBox 5"/>
+            <a:pPr algn="l">
+              <a:defRPr sz="2600" b="1">
+                <a:solidFill>
+                  <a:srgbClr val="0F172A"/>
+                </a:solidFill>
+                <a:latin typeface="Segoe UI"/>
+              </a:defRPr>
+            </a:pPr>
+            <a:r>
+              <a:t>Everything runs in containers with one command</a:t>
+            </a:r>
+          </a:p>
+        </p:txBody>
+      </p:sp>
+      <p:sp>
+        <p:nvSpPr>
+          <p:cNvPr id="7" name="TextBox 6"/>
           <p:cNvSpPr txBox="1"/>
           <p:nvPr/>
         </p:nvSpPr>
         <p:spPr>
           <a:xfrm>
-            <a:off x="640080" y="685800"/>
-            <a:ext cx="10927080" cy="640080"/>
+            <a:off x="640080" y="1417320"/>
+            <a:ext cx="10927080" cy="274320"/>
           </a:xfrm>
           <a:prstGeom prst="rect">
             <a:avLst/>
@@ -8819,48 +8369,12 @@
           <a:noFill/>
         </p:spPr>
         <p:txBody>
-          <a:bodyPr wrap="square" lIns="0" rIns="0" tIns="0" bIns="0">
+          <a:bodyPr wrap="square" lIns="0" tIns="0" rIns="0" bIns="0">
             <a:spAutoFit/>
           </a:bodyPr>
           <a:lstStyle/>
           <a:p>
             <a:pPr algn="l">
-              <a:defRPr sz="2600" b="1">
-                <a:solidFill>
-                  <a:srgbClr val="0F172A"/>
-                </a:solidFill>
-                <a:latin typeface="Segoe UI"/>
-              </a:defRPr>
-            </a:pPr>
-            <a:r>
-              <a:t>Everything runs in containers with one command</a:t>
-            </a:r>
-          </a:p>
-        </p:txBody>
-      </p:sp>
-      <p:sp>
-        <p:nvSpPr>
-          <p:cNvPr id="7" name="TextBox 6"/>
-          <p:cNvSpPr txBox="1"/>
-          <p:nvPr/>
-        </p:nvSpPr>
-        <p:spPr>
-          <a:xfrm>
-            <a:off x="640080" y="1417320"/>
-            <a:ext cx="10927080" cy="274320"/>
-          </a:xfrm>
-          <a:prstGeom prst="rect">
-            <a:avLst/>
-          </a:prstGeom>
-          <a:noFill/>
-        </p:spPr>
-        <p:txBody>
-          <a:bodyPr wrap="square" lIns="0" rIns="0" tIns="0" bIns="0">
-            <a:spAutoFit/>
-          </a:bodyPr>
-          <a:lstStyle/>
-          <a:p>
-            <a:pPr algn="l">
               <a:defRPr sz="1500" b="1">
                 <a:solidFill>
                   <a:srgbClr val="0284C7"/>
@@ -8891,7 +8405,7 @@
           <a:noFill/>
         </p:spPr>
         <p:txBody>
-          <a:bodyPr wrap="square" lIns="0" rIns="0" tIns="0" bIns="0">
+          <a:bodyPr wrap="square" lIns="0" tIns="0" rIns="0" bIns="0">
             <a:spAutoFit/>
           </a:bodyPr>
           <a:lstStyle/>
@@ -8943,7 +8457,7 @@
           <a:noFill/>
         </p:spPr>
         <p:txBody>
-          <a:bodyPr wrap="square" lIns="0" rIns="0" tIns="0" bIns="0">
+          <a:bodyPr wrap="square" lIns="0" tIns="0" rIns="0" bIns="0">
             <a:spAutoFit/>
           </a:bodyPr>
           <a:lstStyle/>
@@ -9023,6 +8537,7 @@
           <a:lstStyle/>
           <a:p>
             <a:pPr algn="ctr"/>
+            <a:endParaRPr/>
           </a:p>
         </p:txBody>
       </p:sp>
@@ -9050,42 +8565,6 @@
           </a:prstGeom>
         </p:spPr>
       </p:pic>
-      <p:sp>
-        <p:nvSpPr>
-          <p:cNvPr id="12" name="TextBox 11"/>
-          <p:cNvSpPr txBox="1"/>
-          <p:nvPr/>
-        </p:nvSpPr>
-        <p:spPr>
-          <a:xfrm>
-            <a:off x="640080" y="6309360"/>
-            <a:ext cx="10927080" cy="320040"/>
-          </a:xfrm>
-          <a:prstGeom prst="rect">
-            <a:avLst/>
-          </a:prstGeom>
-          <a:noFill/>
-        </p:spPr>
-        <p:txBody>
-          <a:bodyPr wrap="square" lIns="0" rIns="0" tIns="0" bIns="0">
-            <a:spAutoFit/>
-          </a:bodyPr>
-          <a:lstStyle/>
-          <a:p>
-            <a:pPr algn="l">
-              <a:defRPr sz="1000" b="0">
-                <a:solidFill>
-                  <a:srgbClr val="64748B"/>
-                </a:solidFill>
-                <a:latin typeface="Segoe UI"/>
-              </a:defRPr>
-            </a:pPr>
-            <a:r>
-              <a:t>screenshot/docker/terminal.png - all three services started by Docker Compose</a:t>
-            </a:r>
-          </a:p>
-        </p:txBody>
-      </p:sp>
     </p:spTree>
   </p:cSld>
   <p:clrMapOvr>
@@ -9095,7 +8574,7 @@
 </file>
 
 <file path=ppt/slides/slide7.xml><?xml version="1.0" encoding="utf-8"?>
-<p:sld xmlns:a="http://schemas.openxmlformats.org/drawingml/2006/main" xmlns:p="http://schemas.openxmlformats.org/presentationml/2006/main" xmlns:r="http://schemas.openxmlformats.org/officeDocument/2006/relationships">
+<p:sld xmlns:a="http://schemas.openxmlformats.org/drawingml/2006/main" xmlns:r="http://schemas.openxmlformats.org/officeDocument/2006/relationships" xmlns:p="http://schemas.openxmlformats.org/presentationml/2006/main">
   <p:cSld>
     <p:spTree>
       <p:nvGrpSpPr>
@@ -9103,7 +8582,14 @@
         <p:cNvGrpSpPr/>
         <p:nvPr/>
       </p:nvGrpSpPr>
-      <p:grpSpPr/>
+      <p:grpSpPr>
+        <a:xfrm>
+          <a:off x="0" y="0"/>
+          <a:ext cx="0" cy="0"/>
+          <a:chOff x="0" y="0"/>
+          <a:chExt cx="0" cy="0"/>
+        </a:xfrm>
+      </p:grpSpPr>
       <p:sp>
         <p:nvSpPr>
           <p:cNvPr id="2" name="Rectangle 1"/>
@@ -9145,6 +8631,7 @@
           <a:lstStyle/>
           <a:p>
             <a:pPr algn="ctr"/>
+            <a:endParaRPr/>
           </a:p>
         </p:txBody>
       </p:sp>
@@ -9189,6 +8676,7 @@
           <a:lstStyle/>
           <a:p>
             <a:pPr algn="ctr"/>
+            <a:endParaRPr/>
           </a:p>
         </p:txBody>
       </p:sp>
@@ -9209,7 +8697,7 @@
           <a:noFill/>
         </p:spPr>
         <p:txBody>
-          <a:bodyPr wrap="square" lIns="0" rIns="0" tIns="0" bIns="0">
+          <a:bodyPr wrap="square" lIns="0" tIns="0" rIns="0" bIns="0">
             <a:spAutoFit/>
           </a:bodyPr>
           <a:lstStyle/>
@@ -9230,42 +8718,6 @@
       </p:sp>
       <p:sp>
         <p:nvSpPr>
-          <p:cNvPr id="5" name="TextBox 4"/>
-          <p:cNvSpPr txBox="1"/>
-          <p:nvPr/>
-        </p:nvSpPr>
-        <p:spPr>
-          <a:xfrm>
-            <a:off x="8412480" y="292608"/>
-            <a:ext cx="3154680" cy="320040"/>
-          </a:xfrm>
-          <a:prstGeom prst="rect">
-            <a:avLst/>
-          </a:prstGeom>
-          <a:noFill/>
-        </p:spPr>
-        <p:txBody>
-          <a:bodyPr wrap="square" lIns="0" rIns="0" tIns="0" bIns="0">
-            <a:spAutoFit/>
-          </a:bodyPr>
-          <a:lstStyle/>
-          <a:p>
-            <a:pPr algn="r">
-              <a:defRPr sz="1200" b="1">
-                <a:solidFill>
-                  <a:srgbClr val="059669"/>
-                </a:solidFill>
-                <a:latin typeface="Segoe UI"/>
-              </a:defRPr>
-            </a:pPr>
-            <a:r>
-              <a:t>Pipeline green</a:t>
-            </a:r>
-          </a:p>
-        </p:txBody>
-      </p:sp>
-      <p:sp>
-        <p:nvSpPr>
           <p:cNvPr id="6" name="TextBox 5"/>
           <p:cNvSpPr txBox="1"/>
           <p:nvPr/>
@@ -9281,7 +8733,7 @@
           <a:noFill/>
         </p:spPr>
         <p:txBody>
-          <a:bodyPr wrap="square" lIns="0" rIns="0" tIns="0" bIns="0">
+          <a:bodyPr wrap="square" lIns="0" tIns="0" rIns="0" bIns="0">
             <a:spAutoFit/>
           </a:bodyPr>
           <a:lstStyle/>
@@ -9345,6 +8797,7 @@
           <a:lstStyle/>
           <a:p>
             <a:pPr algn="ctr"/>
+            <a:endParaRPr/>
           </a:p>
         </p:txBody>
       </p:sp>
@@ -9365,7 +8818,7 @@
           <a:noFill/>
         </p:spPr>
         <p:txBody>
-          <a:bodyPr wrap="square" lIns="0" rIns="0" tIns="0" bIns="0">
+          <a:bodyPr wrap="square" lIns="0" tIns="0" rIns="0" bIns="0">
             <a:spAutoFit/>
           </a:bodyPr>
           <a:lstStyle/>
@@ -9525,6 +8978,7 @@
           <a:lstStyle/>
           <a:p>
             <a:pPr algn="ctr"/>
+            <a:endParaRPr/>
           </a:p>
         </p:txBody>
       </p:sp>
@@ -9545,7 +8999,7 @@
           <a:noFill/>
         </p:spPr>
         <p:txBody>
-          <a:bodyPr wrap="square" lIns="0" rIns="0" tIns="0" bIns="0">
+          <a:bodyPr wrap="square" lIns="0" tIns="0" rIns="0" bIns="0">
             <a:spAutoFit/>
           </a:bodyPr>
           <a:lstStyle/>
@@ -9588,42 +9042,6 @@
           </a:prstGeom>
         </p:spPr>
       </p:pic>
-      <p:sp>
-        <p:nvSpPr>
-          <p:cNvPr id="12" name="TextBox 11"/>
-          <p:cNvSpPr txBox="1"/>
-          <p:nvPr/>
-        </p:nvSpPr>
-        <p:spPr>
-          <a:xfrm>
-            <a:off x="640080" y="6309360"/>
-            <a:ext cx="10927080" cy="320040"/>
-          </a:xfrm>
-          <a:prstGeom prst="rect">
-            <a:avLst/>
-          </a:prstGeom>
-          <a:noFill/>
-        </p:spPr>
-        <p:txBody>
-          <a:bodyPr wrap="square" lIns="0" rIns="0" tIns="0" bIns="0">
-            <a:spAutoFit/>
-          </a:bodyPr>
-          <a:lstStyle/>
-          <a:p>
-            <a:pPr algn="l">
-              <a:defRPr sz="1000" b="0">
-                <a:solidFill>
-                  <a:srgbClr val="64748B"/>
-                </a:solidFill>
-                <a:latin typeface="Segoe UI"/>
-              </a:defRPr>
-            </a:pPr>
-            <a:r>
-              <a:t>screenshot/ci-cd/image.png - successful GitHub Actions pipeline run</a:t>
-            </a:r>
-          </a:p>
-        </p:txBody>
-      </p:sp>
     </p:spTree>
   </p:cSld>
   <p:clrMapOvr>
@@ -9633,7 +9051,7 @@
 </file>
 
 <file path=ppt/slides/slide8.xml><?xml version="1.0" encoding="utf-8"?>
-<p:sld xmlns:a="http://schemas.openxmlformats.org/drawingml/2006/main" xmlns:p="http://schemas.openxmlformats.org/presentationml/2006/main" xmlns:r="http://schemas.openxmlformats.org/officeDocument/2006/relationships">
+<p:sld xmlns:a="http://schemas.openxmlformats.org/drawingml/2006/main" xmlns:r="http://schemas.openxmlformats.org/officeDocument/2006/relationships" xmlns:p="http://schemas.openxmlformats.org/presentationml/2006/main">
   <p:cSld>
     <p:spTree>
       <p:nvGrpSpPr>
@@ -9641,7 +9059,14 @@
         <p:cNvGrpSpPr/>
         <p:nvPr/>
       </p:nvGrpSpPr>
-      <p:grpSpPr/>
+      <p:grpSpPr>
+        <a:xfrm>
+          <a:off x="0" y="0"/>
+          <a:ext cx="0" cy="0"/>
+          <a:chOff x="0" y="0"/>
+          <a:chExt cx="0" cy="0"/>
+        </a:xfrm>
+      </p:grpSpPr>
       <p:sp>
         <p:nvSpPr>
           <p:cNvPr id="2" name="Rectangle 1"/>
@@ -9683,6 +9108,7 @@
           <a:lstStyle/>
           <a:p>
             <a:pPr algn="ctr"/>
+            <a:endParaRPr/>
           </a:p>
         </p:txBody>
       </p:sp>
@@ -9727,6 +9153,7 @@
           <a:lstStyle/>
           <a:p>
             <a:pPr algn="ctr"/>
+            <a:endParaRPr/>
           </a:p>
         </p:txBody>
       </p:sp>
@@ -9747,7 +9174,7 @@
           <a:noFill/>
         </p:spPr>
         <p:txBody>
-          <a:bodyPr wrap="square" lIns="0" rIns="0" tIns="0" bIns="0">
+          <a:bodyPr wrap="square" lIns="0" tIns="0" rIns="0" bIns="0">
             <a:spAutoFit/>
           </a:bodyPr>
           <a:lstStyle/>
@@ -9783,7 +9210,7 @@
           <a:noFill/>
         </p:spPr>
         <p:txBody>
-          <a:bodyPr wrap="square" lIns="0" rIns="0" tIns="0" bIns="0">
+          <a:bodyPr wrap="square" lIns="0" tIns="0" rIns="0" bIns="0">
             <a:spAutoFit/>
           </a:bodyPr>
           <a:lstStyle/>
@@ -9819,7 +9246,7 @@
           <a:noFill/>
         </p:spPr>
         <p:txBody>
-          <a:bodyPr wrap="square" lIns="0" rIns="0" tIns="0" bIns="0">
+          <a:bodyPr wrap="square" lIns="0" tIns="0" rIns="0" bIns="0">
             <a:spAutoFit/>
           </a:bodyPr>
           <a:lstStyle/>
@@ -9883,6 +9310,7 @@
           <a:lstStyle/>
           <a:p>
             <a:pPr algn="ctr"/>
+            <a:endParaRPr/>
           </a:p>
         </p:txBody>
       </p:sp>
@@ -9903,7 +9331,7 @@
           <a:noFill/>
         </p:spPr>
         <p:txBody>
-          <a:bodyPr wrap="square" lIns="0" rIns="0" tIns="0" bIns="0">
+          <a:bodyPr wrap="square" lIns="0" tIns="0" rIns="0" bIns="0">
             <a:spAutoFit/>
           </a:bodyPr>
           <a:lstStyle/>
@@ -10063,6 +9491,7 @@
           <a:lstStyle/>
           <a:p>
             <a:pPr algn="ctr"/>
+            <a:endParaRPr/>
           </a:p>
         </p:txBody>
       </p:sp>
@@ -10083,7 +9512,7 @@
           <a:noFill/>
         </p:spPr>
         <p:txBody>
-          <a:bodyPr wrap="square" lIns="0" rIns="0" tIns="0" bIns="0">
+          <a:bodyPr wrap="square" lIns="0" tIns="0" rIns="0" bIns="0">
             <a:spAutoFit/>
           </a:bodyPr>
           <a:lstStyle/>
@@ -10143,7 +9572,7 @@
           <a:noFill/>
         </p:spPr>
         <p:txBody>
-          <a:bodyPr wrap="square" lIns="0" rIns="0" tIns="0" bIns="0">
+          <a:bodyPr wrap="square" lIns="0" tIns="0" rIns="0" bIns="0">
             <a:spAutoFit/>
           </a:bodyPr>
           <a:lstStyle/>
@@ -10171,7 +9600,7 @@
 </file>
 
 <file path=ppt/slides/slide9.xml><?xml version="1.0" encoding="utf-8"?>
-<p:sld xmlns:a="http://schemas.openxmlformats.org/drawingml/2006/main" xmlns:p="http://schemas.openxmlformats.org/presentationml/2006/main" xmlns:r="http://schemas.openxmlformats.org/officeDocument/2006/relationships">
+<p:sld xmlns:a="http://schemas.openxmlformats.org/drawingml/2006/main" xmlns:r="http://schemas.openxmlformats.org/officeDocument/2006/relationships" xmlns:p="http://schemas.openxmlformats.org/presentationml/2006/main">
   <p:cSld>
     <p:spTree>
       <p:nvGrpSpPr>
@@ -10179,7 +9608,14 @@
         <p:cNvGrpSpPr/>
         <p:nvPr/>
       </p:nvGrpSpPr>
-      <p:grpSpPr/>
+      <p:grpSpPr>
+        <a:xfrm>
+          <a:off x="0" y="0"/>
+          <a:ext cx="0" cy="0"/>
+          <a:chOff x="0" y="0"/>
+          <a:chExt cx="0" cy="0"/>
+        </a:xfrm>
+      </p:grpSpPr>
       <p:sp>
         <p:nvSpPr>
           <p:cNvPr id="2" name="Rectangle 1"/>
@@ -10221,6 +9657,7 @@
           <a:lstStyle/>
           <a:p>
             <a:pPr algn="ctr"/>
+            <a:endParaRPr/>
           </a:p>
         </p:txBody>
       </p:sp>
@@ -10265,6 +9702,7 @@
           <a:lstStyle/>
           <a:p>
             <a:pPr algn="ctr"/>
+            <a:endParaRPr/>
           </a:p>
         </p:txBody>
       </p:sp>
@@ -10285,7 +9723,7 @@
           <a:noFill/>
         </p:spPr>
         <p:txBody>
-          <a:bodyPr wrap="square" lIns="0" rIns="0" tIns="0" bIns="0">
+          <a:bodyPr wrap="square" lIns="0" tIns="0" rIns="0" bIns="0">
             <a:spAutoFit/>
           </a:bodyPr>
           <a:lstStyle/>
@@ -10306,14 +9744,14 @@
       </p:sp>
       <p:sp>
         <p:nvSpPr>
-          <p:cNvPr id="5" name="TextBox 4"/>
+          <p:cNvPr id="6" name="TextBox 5"/>
           <p:cNvSpPr txBox="1"/>
           <p:nvPr/>
         </p:nvSpPr>
         <p:spPr>
           <a:xfrm>
-            <a:off x="8412480" y="292608"/>
-            <a:ext cx="3154680" cy="320040"/>
+            <a:off x="640080" y="685800"/>
+            <a:ext cx="10927080" cy="640080"/>
           </a:xfrm>
           <a:prstGeom prst="rect">
             <a:avLst/>
@@ -10321,35 +9759,35 @@
           <a:noFill/>
         </p:spPr>
         <p:txBody>
-          <a:bodyPr wrap="square" lIns="0" rIns="0" tIns="0" bIns="0">
+          <a:bodyPr wrap="square" lIns="0" tIns="0" rIns="0" bIns="0">
             <a:spAutoFit/>
           </a:bodyPr>
           <a:lstStyle/>
           <a:p>
-            <a:pPr algn="r">
-              <a:defRPr sz="1200" b="1">
-                <a:solidFill>
-                  <a:srgbClr val="059669"/>
-                </a:solidFill>
-                <a:latin typeface="Segoe UI"/>
-              </a:defRPr>
-            </a:pPr>
-            <a:r>
-              <a:t>Release deployed</a:t>
-            </a:r>
-          </a:p>
-        </p:txBody>
-      </p:sp>
-      <p:sp>
-        <p:nvSpPr>
-          <p:cNvPr id="6" name="TextBox 5"/>
+            <a:pPr algn="l">
+              <a:defRPr sz="2600" b="1">
+                <a:solidFill>
+                  <a:srgbClr val="0F172A"/>
+                </a:solidFill>
+                <a:latin typeface="Segoe UI"/>
+              </a:defRPr>
+            </a:pPr>
+            <a:r>
+              <a:t>The app deployed to Kubernetes with Helm</a:t>
+            </a:r>
+          </a:p>
+        </p:txBody>
+      </p:sp>
+      <p:sp>
+        <p:nvSpPr>
+          <p:cNvPr id="7" name="TextBox 6"/>
           <p:cNvSpPr txBox="1"/>
           <p:nvPr/>
         </p:nvSpPr>
         <p:spPr>
           <a:xfrm>
-            <a:off x="640080" y="685800"/>
-            <a:ext cx="10927080" cy="640080"/>
+            <a:off x="640080" y="1417320"/>
+            <a:ext cx="10927080" cy="274320"/>
           </a:xfrm>
           <a:prstGeom prst="rect">
             <a:avLst/>
@@ -10357,48 +9795,12 @@
           <a:noFill/>
         </p:spPr>
         <p:txBody>
-          <a:bodyPr wrap="square" lIns="0" rIns="0" tIns="0" bIns="0">
+          <a:bodyPr wrap="square" lIns="0" tIns="0" rIns="0" bIns="0">
             <a:spAutoFit/>
           </a:bodyPr>
           <a:lstStyle/>
           <a:p>
             <a:pPr algn="l">
-              <a:defRPr sz="2600" b="1">
-                <a:solidFill>
-                  <a:srgbClr val="0F172A"/>
-                </a:solidFill>
-                <a:latin typeface="Segoe UI"/>
-              </a:defRPr>
-            </a:pPr>
-            <a:r>
-              <a:t>The app deployed to Kubernetes with Helm</a:t>
-            </a:r>
-          </a:p>
-        </p:txBody>
-      </p:sp>
-      <p:sp>
-        <p:nvSpPr>
-          <p:cNvPr id="7" name="TextBox 6"/>
-          <p:cNvSpPr txBox="1"/>
-          <p:nvPr/>
-        </p:nvSpPr>
-        <p:spPr>
-          <a:xfrm>
-            <a:off x="640080" y="1417320"/>
-            <a:ext cx="10927080" cy="274320"/>
-          </a:xfrm>
-          <a:prstGeom prst="rect">
-            <a:avLst/>
-          </a:prstGeom>
-          <a:noFill/>
-        </p:spPr>
-        <p:txBody>
-          <a:bodyPr wrap="square" lIns="0" rIns="0" tIns="0" bIns="0">
-            <a:spAutoFit/>
-          </a:bodyPr>
-          <a:lstStyle/>
-          <a:p>
-            <a:pPr algn="l">
               <a:defRPr sz="1500" b="1">
                 <a:solidFill>
                   <a:srgbClr val="0284C7"/>
@@ -10429,7 +9831,7 @@
           <a:noFill/>
         </p:spPr>
         <p:txBody>
-          <a:bodyPr wrap="square" lIns="0" rIns="0" tIns="0" bIns="0">
+          <a:bodyPr wrap="square" lIns="0" tIns="0" rIns="0" bIns="0">
             <a:spAutoFit/>
           </a:bodyPr>
           <a:lstStyle/>
@@ -10481,7 +9883,7 @@
           <a:noFill/>
         </p:spPr>
         <p:txBody>
-          <a:bodyPr wrap="square" lIns="0" rIns="0" tIns="0" bIns="0">
+          <a:bodyPr wrap="square" lIns="0" tIns="0" rIns="0" bIns="0">
             <a:spAutoFit/>
           </a:bodyPr>
           <a:lstStyle/>
@@ -10561,6 +9963,7 @@
           <a:lstStyle/>
           <a:p>
             <a:pPr algn="ctr"/>
+            <a:endParaRPr/>
           </a:p>
         </p:txBody>
       </p:sp>
@@ -10588,42 +9991,6 @@
           </a:prstGeom>
         </p:spPr>
       </p:pic>
-      <p:sp>
-        <p:nvSpPr>
-          <p:cNvPr id="12" name="TextBox 11"/>
-          <p:cNvSpPr txBox="1"/>
-          <p:nvPr/>
-        </p:nvSpPr>
-        <p:spPr>
-          <a:xfrm>
-            <a:off x="640080" y="6309360"/>
-            <a:ext cx="10927080" cy="320040"/>
-          </a:xfrm>
-          <a:prstGeom prst="rect">
-            <a:avLst/>
-          </a:prstGeom>
-          <a:noFill/>
-        </p:spPr>
-        <p:txBody>
-          <a:bodyPr wrap="square" lIns="0" rIns="0" tIns="0" bIns="0">
-            <a:spAutoFit/>
-          </a:bodyPr>
-          <a:lstStyle/>
-          <a:p>
-            <a:pPr algn="l">
-              <a:defRPr sz="1000" b="0">
-                <a:solidFill>
-                  <a:srgbClr val="64748B"/>
-                </a:solidFill>
-                <a:latin typeface="Segoe UI"/>
-              </a:defRPr>
-            </a:pPr>
-            <a:r>
-              <a:t>screenshot/helm/service&amp;list.png - Helm release and Kubernetes services</a:t>
-            </a:r>
-          </a:p>
-        </p:txBody>
-      </p:sp>
     </p:spTree>
   </p:cSld>
   <p:clrMapOvr>

</xml_diff>